<commit_message>
Add CloudWatch CPU alarm and SNS email notification via Terraform
- Added infrastructure/cloudwatch.tf:
  - aws_sns_topic: notification channel for CPU alerts
  - aws_sns_topic_subscription: email subscription (alert_email var)
  - aws_cloudwatch_metric_alarm: fires when EC2 CPU > 80% for 5 min
  - Output: prints SNS topic ARN after apply
- Added alert_email variable to infrastructure/variables.tf
- Updated AWS architecture diagram
</commit_message>
<xml_diff>
--- a/Assets/AWS_Architecture.pptx
+++ b/Assets/AWS_Architecture.pptx
@@ -4,13 +4,13 @@
   <p:sldMasterIdLst>
     <p:sldMasterId id="2147483648" r:id="rId1"/>
   </p:sldMasterIdLst>
+  <p:notesMasterIdLst>
+    <p:notesMasterId r:id="rId3"/>
+  </p:notesMasterIdLst>
   <p:sldIdLst>
     <p:sldId id="256" r:id="rId2"/>
   </p:sldIdLst>
-  <p:notesMasterIdLst>
-    <p:notesMasterId r:id="rId3"/>
-  </p:notesMasterIdLst>
-  <p:sldSz cx="9144000" cy="5143500"/>
+  <p:sldSz cx="9144000" cy="5143500" type="screen16x9"/>
   <p:notesSz cx="5143500" cy="9144000"/>
   <p:defaultTextStyle>
     <a:lvl1pPr marL="0" algn="l" defTabSz="914400" rtl="0" eaLnBrk="1" latinLnBrk="0" hangingPunct="1">
@@ -104,6 +104,11 @@
       </a:defRPr>
     </a:lvl9pPr>
   </p:defaultTextStyle>
+  <p:extLst>
+    <p:ext uri="{EFAFB233-063F-42B5-8137-9DF3F51BA10A}">
+      <p15:sldGuideLst xmlns:p15="http://schemas.microsoft.com/office/powerpoint/2012/main"/>
+    </p:ext>
+  </p:extLst>
 </p:presentation>
 </file>
 
@@ -129,234 +134,10 @@
           <a:chExt cx="0" cy="0"/>
         </a:xfrm>
       </p:grpSpPr>
-      <p:sp>
-        <p:nvSpPr>
-          <p:cNvPr id="2" name="Header Placeholder 1"/>
-          <p:cNvSpPr>
-            <a:spLocks noGrp="1"/>
-          </p:cNvSpPr>
-          <p:nvPr>
-            <p:ph type="hdr" sz="quarter"/>
-          </p:nvPr>
-        </p:nvSpPr>
-        <p:spPr>
-          <a:xfrm>
-            <a:off x="0" y="0"/>
-            <a:ext cx="2971800" cy="458788"/>
-          </a:xfrm>
-          <a:prstGeom prst="rect">
-            <a:avLst/>
-          </a:prstGeom>
-        </p:spPr>
-        <p:txBody>
-          <a:bodyPr vert="horz" lIns="91440" tIns="45720" rIns="91440" bIns="45720" rtlCol="0"/>
-          <a:lstStyle>
-            <a:lvl1pPr algn="l">
-              <a:defRPr sz="1200"/>
-            </a:lvl1pPr>
-          </a:lstStyle>
-          <a:p>
-            <a:endParaRPr lang="en-US"/>
-          </a:p>
-        </p:txBody>
-      </p:sp>
-      <p:sp>
-        <p:nvSpPr>
-          <p:cNvPr id="3" name="Date Placeholder 2"/>
-          <p:cNvSpPr>
-            <a:spLocks noGrp="1"/>
-          </p:cNvSpPr>
-          <p:nvPr>
-            <p:ph type="dt" idx="1"/>
-          </p:nvPr>
-        </p:nvSpPr>
-        <p:spPr>
-          <a:xfrm>
-            <a:off x="3884613" y="0"/>
-            <a:ext cx="2971800" cy="458788"/>
-          </a:xfrm>
-          <a:prstGeom prst="rect">
-            <a:avLst/>
-          </a:prstGeom>
-        </p:spPr>
-        <p:txBody>
-          <a:bodyPr vert="horz" lIns="91440" tIns="45720" rIns="91440" bIns="45720" rtlCol="0"/>
-          <a:lstStyle>
-            <a:lvl1pPr algn="r">
-              <a:defRPr sz="1200"/>
-            </a:lvl1pPr>
-          </a:lstStyle>
-          <a:p>
-            <a:fld id="{5282F153-3F37-0F45-9E97-73ACFA13230C}" type="datetimeFigureOut">
-              <a:rPr lang="en-US"/>
-              <a:t>7/23/19</a:t>
-            </a:fld>
-            <a:endParaRPr lang="en-US"/>
-          </a:p>
-        </p:txBody>
-      </p:sp>
-      <p:sp>
-        <p:nvSpPr>
-          <p:cNvPr id="4" name="Slide Image Placeholder 3"/>
-          <p:cNvSpPr>
-            <a:spLocks noGrp="1" noRot="1" noChangeAspect="1"/>
-          </p:cNvSpPr>
-          <p:nvPr>
-            <p:ph type="sldImg" idx="2"/>
-          </p:nvPr>
-        </p:nvSpPr>
-        <p:spPr>
-          <a:xfrm>
-            <a:off x="685800" y="1143000"/>
-            <a:ext cx="5486400" cy="3086100"/>
-          </a:xfrm>
-          <a:prstGeom prst="rect">
-            <a:avLst/>
-          </a:prstGeom>
-          <a:noFill/>
-          <a:ln w="12700">
-            <a:solidFill>
-              <a:prstClr val="black"/>
-            </a:solidFill>
-          </a:ln>
-        </p:spPr>
-        <p:txBody>
-          <a:bodyPr vert="horz" lIns="91440" tIns="45720" rIns="91440" bIns="45720" rtlCol="0" anchor="ctr"/>
-          <a:lstStyle/>
-          <a:p>
-            <a:endParaRPr lang="en-US"/>
-          </a:p>
-        </p:txBody>
-      </p:sp>
-      <p:sp>
-        <p:nvSpPr>
-          <p:cNvPr id="5" name="Notes Placeholder 4"/>
-          <p:cNvSpPr>
-            <a:spLocks noGrp="1"/>
-          </p:cNvSpPr>
-          <p:nvPr>
-            <p:ph type="body" sz="quarter" idx="3"/>
-          </p:nvPr>
-        </p:nvSpPr>
-        <p:spPr>
-          <a:xfrm>
-            <a:off x="685800" y="4400550"/>
-            <a:ext cx="5486400" cy="3600450"/>
-          </a:xfrm>
-          <a:prstGeom prst="rect">
-            <a:avLst/>
-          </a:prstGeom>
-        </p:spPr>
-        <p:txBody>
-          <a:bodyPr vert="horz" lIns="91440" tIns="45720" rIns="91440" bIns="45720" rtlCol="0"/>
-          <a:lstStyle/>
-          <a:p>
-            <a:pPr lvl="0"/>
-            <a:r>
-              <a:rPr lang="en-US"/>
-              <a:t>Click to edit Master text styles</a:t>
-            </a:r>
-          </a:p>
-          <a:p>
-            <a:pPr lvl="1"/>
-            <a:r>
-              <a:rPr lang="en-US"/>
-              <a:t>Second level</a:t>
-            </a:r>
-          </a:p>
-          <a:p>
-            <a:pPr lvl="2"/>
-            <a:r>
-              <a:rPr lang="en-US"/>
-              <a:t>Third level</a:t>
-            </a:r>
-          </a:p>
-          <a:p>
-            <a:pPr lvl="3"/>
-            <a:r>
-              <a:rPr lang="en-US"/>
-              <a:t>Fourth level</a:t>
-            </a:r>
-          </a:p>
-          <a:p>
-            <a:pPr lvl="4"/>
-            <a:r>
-              <a:rPr lang="en-US"/>
-              <a:t>Fifth level</a:t>
-            </a:r>
-          </a:p>
-        </p:txBody>
-      </p:sp>
-      <p:sp>
-        <p:nvSpPr>
-          <p:cNvPr id="6" name="Footer Placeholder 5"/>
-          <p:cNvSpPr>
-            <a:spLocks noGrp="1"/>
-          </p:cNvSpPr>
-          <p:nvPr>
-            <p:ph type="ftr" sz="quarter" idx="4"/>
-          </p:nvPr>
-        </p:nvSpPr>
-        <p:spPr>
-          <a:xfrm>
-            <a:off x="0" y="8685213"/>
-            <a:ext cx="2971800" cy="458787"/>
-          </a:xfrm>
-          <a:prstGeom prst="rect">
-            <a:avLst/>
-          </a:prstGeom>
-        </p:spPr>
-        <p:txBody>
-          <a:bodyPr vert="horz" lIns="91440" tIns="45720" rIns="91440" bIns="45720" rtlCol="0" anchor="b"/>
-          <a:lstStyle>
-            <a:lvl1pPr algn="l">
-              <a:defRPr sz="1200"/>
-            </a:lvl1pPr>
-          </a:lstStyle>
-          <a:p>
-            <a:endParaRPr lang="en-US"/>
-          </a:p>
-        </p:txBody>
-      </p:sp>
-      <p:sp>
-        <p:nvSpPr>
-          <p:cNvPr id="7" name="Slide Number Placeholder 6"/>
-          <p:cNvSpPr>
-            <a:spLocks noGrp="1"/>
-          </p:cNvSpPr>
-          <p:nvPr>
-            <p:ph type="sldNum" sz="quarter" idx="5"/>
-          </p:nvPr>
-        </p:nvSpPr>
-        <p:spPr>
-          <a:xfrm>
-            <a:off x="3884613" y="8685213"/>
-            <a:ext cx="2971800" cy="458787"/>
-          </a:xfrm>
-          <a:prstGeom prst="rect">
-            <a:avLst/>
-          </a:prstGeom>
-        </p:spPr>
-        <p:txBody>
-          <a:bodyPr vert="horz" lIns="91440" tIns="45720" rIns="91440" bIns="45720" rtlCol="0" anchor="b"/>
-          <a:lstStyle>
-            <a:lvl1pPr algn="r">
-              <a:defRPr sz="1200"/>
-            </a:lvl1pPr>
-          </a:lstStyle>
-          <a:p>
-            <a:fld id="{CE5E9CC1-C706-0F49-92D6-E571CC5EEA8F}" type="slidenum">
-              <a:rPr lang="en-US"/>
-              <a:t>‹#›</a:t>
-            </a:fld>
-            <a:endParaRPr lang="en-US"/>
-          </a:p>
-        </p:txBody>
-      </p:sp>
     </p:spTree>
     <p:extLst>
       <p:ext uri="{BB962C8B-B14F-4D97-AF65-F5344CB8AC3E}">
-        <p14:creationId xmlns:p14="http://schemas.microsoft.com/office/powerpoint/2010/main" val="1024086991"/>
+        <p14:creationId xmlns:p14="http://schemas.microsoft.com/office/powerpoint/2010/main" val="910708791"/>
       </p:ext>
     </p:extLst>
   </p:cSld>
@@ -500,10 +281,6 @@
           <a:bodyPr/>
           <a:lstStyle/>
           <a:p>
-            <a:r>
-              <a:rPr lang="en-US" dirty="0"/>
-              <a:t/>
-            </a:r>
             <a:endParaRPr lang="en-US" dirty="0"/>
           </a:p>
         </p:txBody>
@@ -577,6 +354,11 @@
 <file path=ppt/slideMasters/slideMaster1.xml><?xml version="1.0" encoding="utf-8"?>
 <p:sldMaster xmlns:a="http://schemas.openxmlformats.org/drawingml/2006/main" xmlns:r="http://schemas.openxmlformats.org/officeDocument/2006/relationships" xmlns:p="http://schemas.openxmlformats.org/presentationml/2006/main">
   <p:cSld>
+    <p:bg>
+      <p:bgRef idx="1001">
+        <a:schemeClr val="bg1"/>
+      </p:bgRef>
+    </p:bg>
     <p:spTree>
       <p:nvGrpSpPr>
         <p:cNvPr id="1" name=""/>
@@ -859,6 +641,7 @@
         <a:solidFill>
           <a:srgbClr val="0D1B2A"/>
         </a:solidFill>
+        <a:effectLst/>
       </p:bgPr>
     </p:bg>
     <p:spTree>
@@ -883,7 +666,7 @@
         </p:nvSpPr>
         <p:spPr>
           <a:xfrm>
-            <a:off x="365760" y="182880"/>
+            <a:off x="365760" y="164592"/>
             <a:ext cx="8412480" cy="502920"/>
           </a:xfrm>
           <a:prstGeom prst="rect">
@@ -896,7 +679,7 @@
           <a:bodyPr wrap="square" lIns="0" tIns="0" rIns="0" bIns="0" rtlCol="0" anchor="ctr"/>
           <a:lstStyle/>
           <a:p>
-            <a:pPr algn="l" indent="0" marL="0">
+            <a:pPr marL="0" indent="0" algn="l">
               <a:buNone/>
             </a:pPr>
             <a:r>
@@ -922,8 +705,8 @@
         </p:nvSpPr>
         <p:spPr>
           <a:xfrm>
-            <a:off x="365760" y="658368"/>
-            <a:ext cx="8412480" cy="292608"/>
+            <a:off x="365760" y="640080"/>
+            <a:ext cx="8412480" cy="274320"/>
           </a:xfrm>
           <a:prstGeom prst="rect">
             <a:avLst/>
@@ -935,19 +718,19 @@
           <a:bodyPr wrap="square" lIns="0" tIns="0" rIns="0" bIns="0" rtlCol="0" anchor="ctr"/>
           <a:lstStyle/>
           <a:p>
-            <a:pPr algn="l" indent="0" marL="0">
+            <a:pPr marL="0" indent="0" algn="l">
               <a:buNone/>
             </a:pPr>
             <a:r>
               <a:rPr lang="en-US" sz="1300" dirty="0">
                 <a:solidFill>
-                  <a:srgbClr val="6B8BAE"/>
+                  <a:srgbClr val="5A7A9A"/>
                 </a:solidFill>
                 <a:latin typeface="Calibri" pitchFamily="34" charset="0"/>
                 <a:ea typeface="Calibri" pitchFamily="34" charset="-122"/>
                 <a:cs typeface="Calibri" pitchFamily="34" charset="-120"/>
               </a:rPr>
-              <a:t>Grocery Store Project · Masterschools</a:t>
+              <a:t>Grocery Store</a:t>
             </a:r>
             <a:endParaRPr lang="en-US" sz="1300" dirty="0"/>
           </a:p>
@@ -961,14 +744,195 @@
         </p:nvSpPr>
         <p:spPr>
           <a:xfrm>
-            <a:off x="2011680" y="1051560"/>
-            <a:ext cx="6766560" cy="3749040"/>
-          </a:xfrm>
-          <a:prstGeom prst="rect">
-            <a:avLst/>
-          </a:prstGeom>
-          <a:solidFill>
-            <a:srgbClr val="1A2F48"/>
+            <a:off x="2045970" y="983557"/>
+            <a:ext cx="6803136" cy="3725604"/>
+          </a:xfrm>
+          <a:custGeom>
+            <a:avLst/>
+            <a:gdLst>
+              <a:gd name="csX0" fmla="*/ 0 w 6803136"/>
+              <a:gd name="csY0" fmla="*/ 0 h 3685032"/>
+              <a:gd name="csX1" fmla="*/ 6803136 w 6803136"/>
+              <a:gd name="csY1" fmla="*/ 0 h 3685032"/>
+              <a:gd name="csX2" fmla="*/ 6803136 w 6803136"/>
+              <a:gd name="csY2" fmla="*/ 3685032 h 3685032"/>
+              <a:gd name="csX3" fmla="*/ 0 w 6803136"/>
+              <a:gd name="csY3" fmla="*/ 3685032 h 3685032"/>
+              <a:gd name="csX4" fmla="*/ 0 w 6803136"/>
+              <a:gd name="csY4" fmla="*/ 0 h 3685032"/>
+              <a:gd name="csX0" fmla="*/ 0 w 6803136"/>
+              <a:gd name="csY0" fmla="*/ 0 h 3685032"/>
+              <a:gd name="csX1" fmla="*/ 6795452 w 6803136"/>
+              <a:gd name="csY1" fmla="*/ 0 h 3685032"/>
+              <a:gd name="csX2" fmla="*/ 6803136 w 6803136"/>
+              <a:gd name="csY2" fmla="*/ 3685032 h 3685032"/>
+              <a:gd name="csX3" fmla="*/ 0 w 6803136"/>
+              <a:gd name="csY3" fmla="*/ 3685032 h 3685032"/>
+              <a:gd name="csX4" fmla="*/ 0 w 6803136"/>
+              <a:gd name="csY4" fmla="*/ 0 h 3685032"/>
+              <a:gd name="csX0" fmla="*/ 0 w 6803136"/>
+              <a:gd name="csY0" fmla="*/ 0 h 3685032"/>
+              <a:gd name="csX1" fmla="*/ 6795452 w 6803136"/>
+              <a:gd name="csY1" fmla="*/ 0 h 3685032"/>
+              <a:gd name="csX2" fmla="*/ 6803136 w 6803136"/>
+              <a:gd name="csY2" fmla="*/ 3685032 h 3685032"/>
+              <a:gd name="csX3" fmla="*/ 0 w 6803136"/>
+              <a:gd name="csY3" fmla="*/ 3685032 h 3685032"/>
+              <a:gd name="csX4" fmla="*/ 0 w 6803136"/>
+              <a:gd name="csY4" fmla="*/ 0 h 3685032"/>
+              <a:gd name="csX0" fmla="*/ 0 w 6803136"/>
+              <a:gd name="csY0" fmla="*/ 0 h 3685032"/>
+              <a:gd name="csX1" fmla="*/ 6795452 w 6803136"/>
+              <a:gd name="csY1" fmla="*/ 0 h 3685032"/>
+              <a:gd name="csX2" fmla="*/ 6803136 w 6803136"/>
+              <a:gd name="csY2" fmla="*/ 3685032 h 3685032"/>
+              <a:gd name="csX3" fmla="*/ 0 w 6803136"/>
+              <a:gd name="csY3" fmla="*/ 3685032 h 3685032"/>
+              <a:gd name="csX4" fmla="*/ 0 w 6803136"/>
+              <a:gd name="csY4" fmla="*/ 0 h 3685032"/>
+              <a:gd name="csX0" fmla="*/ 0 w 6803136"/>
+              <a:gd name="csY0" fmla="*/ 376518 h 4061550"/>
+              <a:gd name="csX1" fmla="*/ 6780084 w 6803136"/>
+              <a:gd name="csY1" fmla="*/ 0 h 4061550"/>
+              <a:gd name="csX2" fmla="*/ 6803136 w 6803136"/>
+              <a:gd name="csY2" fmla="*/ 4061550 h 4061550"/>
+              <a:gd name="csX3" fmla="*/ 0 w 6803136"/>
+              <a:gd name="csY3" fmla="*/ 4061550 h 4061550"/>
+              <a:gd name="csX4" fmla="*/ 0 w 6803136"/>
+              <a:gd name="csY4" fmla="*/ 376518 h 4061550"/>
+              <a:gd name="csX0" fmla="*/ 0 w 6803136"/>
+              <a:gd name="csY0" fmla="*/ 46105 h 3731137"/>
+              <a:gd name="csX1" fmla="*/ 6795452 w 6803136"/>
+              <a:gd name="csY1" fmla="*/ 0 h 3731137"/>
+              <a:gd name="csX2" fmla="*/ 6803136 w 6803136"/>
+              <a:gd name="csY2" fmla="*/ 3731137 h 3731137"/>
+              <a:gd name="csX3" fmla="*/ 0 w 6803136"/>
+              <a:gd name="csY3" fmla="*/ 3731137 h 3731137"/>
+              <a:gd name="csX4" fmla="*/ 0 w 6803136"/>
+              <a:gd name="csY4" fmla="*/ 46105 h 3731137"/>
+              <a:gd name="csX0" fmla="*/ 0 w 6803136"/>
+              <a:gd name="csY0" fmla="*/ 46105 h 3731137"/>
+              <a:gd name="csX1" fmla="*/ 2683649 w 6803136"/>
+              <a:gd name="csY1" fmla="*/ 13217 h 3731137"/>
+              <a:gd name="csX2" fmla="*/ 6795452 w 6803136"/>
+              <a:gd name="csY2" fmla="*/ 0 h 3731137"/>
+              <a:gd name="csX3" fmla="*/ 6803136 w 6803136"/>
+              <a:gd name="csY3" fmla="*/ 3731137 h 3731137"/>
+              <a:gd name="csX4" fmla="*/ 0 w 6803136"/>
+              <a:gd name="csY4" fmla="*/ 3731137 h 3731137"/>
+              <a:gd name="csX5" fmla="*/ 0 w 6803136"/>
+              <a:gd name="csY5" fmla="*/ 46105 h 3731137"/>
+              <a:gd name="csX0" fmla="*/ 0 w 6803136"/>
+              <a:gd name="csY0" fmla="*/ 46105 h 3731137"/>
+              <a:gd name="csX1" fmla="*/ 2675965 w 6803136"/>
+              <a:gd name="csY1" fmla="*/ 5533 h 3731137"/>
+              <a:gd name="csX2" fmla="*/ 6795452 w 6803136"/>
+              <a:gd name="csY2" fmla="*/ 0 h 3731137"/>
+              <a:gd name="csX3" fmla="*/ 6803136 w 6803136"/>
+              <a:gd name="csY3" fmla="*/ 3731137 h 3731137"/>
+              <a:gd name="csX4" fmla="*/ 0 w 6803136"/>
+              <a:gd name="csY4" fmla="*/ 3731137 h 3731137"/>
+              <a:gd name="csX5" fmla="*/ 0 w 6803136"/>
+              <a:gd name="csY5" fmla="*/ 46105 h 3731137"/>
+              <a:gd name="csX0" fmla="*/ 0 w 6803136"/>
+              <a:gd name="csY0" fmla="*/ 48256 h 3733288"/>
+              <a:gd name="csX1" fmla="*/ 2675965 w 6803136"/>
+              <a:gd name="csY1" fmla="*/ 7684 h 3733288"/>
+              <a:gd name="csX2" fmla="*/ 2660597 w 6803136"/>
+              <a:gd name="csY2" fmla="*/ 0 h 3733288"/>
+              <a:gd name="csX3" fmla="*/ 6795452 w 6803136"/>
+              <a:gd name="csY3" fmla="*/ 2151 h 3733288"/>
+              <a:gd name="csX4" fmla="*/ 6803136 w 6803136"/>
+              <a:gd name="csY4" fmla="*/ 3733288 h 3733288"/>
+              <a:gd name="csX5" fmla="*/ 0 w 6803136"/>
+              <a:gd name="csY5" fmla="*/ 3733288 h 3733288"/>
+              <a:gd name="csX6" fmla="*/ 0 w 6803136"/>
+              <a:gd name="csY6" fmla="*/ 48256 h 3733288"/>
+              <a:gd name="csX0" fmla="*/ 0 w 6803136"/>
+              <a:gd name="csY0" fmla="*/ 46105 h 3731137"/>
+              <a:gd name="csX1" fmla="*/ 2675965 w 6803136"/>
+              <a:gd name="csY1" fmla="*/ 5533 h 3731137"/>
+              <a:gd name="csX2" fmla="*/ 2675965 w 6803136"/>
+              <a:gd name="csY2" fmla="*/ 1012142 h 3731137"/>
+              <a:gd name="csX3" fmla="*/ 6795452 w 6803136"/>
+              <a:gd name="csY3" fmla="*/ 0 h 3731137"/>
+              <a:gd name="csX4" fmla="*/ 6803136 w 6803136"/>
+              <a:gd name="csY4" fmla="*/ 3731137 h 3731137"/>
+              <a:gd name="csX5" fmla="*/ 0 w 6803136"/>
+              <a:gd name="csY5" fmla="*/ 3731137 h 3731137"/>
+              <a:gd name="csX6" fmla="*/ 0 w 6803136"/>
+              <a:gd name="csY6" fmla="*/ 46105 h 3731137"/>
+              <a:gd name="csX0" fmla="*/ 0 w 6803136"/>
+              <a:gd name="csY0" fmla="*/ 40572 h 3725604"/>
+              <a:gd name="csX1" fmla="*/ 2675965 w 6803136"/>
+              <a:gd name="csY1" fmla="*/ 0 h 3725604"/>
+              <a:gd name="csX2" fmla="*/ 2675965 w 6803136"/>
+              <a:gd name="csY2" fmla="*/ 1006609 h 3725604"/>
+              <a:gd name="csX3" fmla="*/ 6787768 w 6803136"/>
+              <a:gd name="csY3" fmla="*/ 993392 h 3725604"/>
+              <a:gd name="csX4" fmla="*/ 6803136 w 6803136"/>
+              <a:gd name="csY4" fmla="*/ 3725604 h 3725604"/>
+              <a:gd name="csX5" fmla="*/ 0 w 6803136"/>
+              <a:gd name="csY5" fmla="*/ 3725604 h 3725604"/>
+              <a:gd name="csX6" fmla="*/ 0 w 6803136"/>
+              <a:gd name="csY6" fmla="*/ 40572 h 3725604"/>
+            </a:gdLst>
+            <a:ahLst/>
+            <a:cxnLst>
+              <a:cxn ang="0">
+                <a:pos x="csX0" y="csY0"/>
+              </a:cxn>
+              <a:cxn ang="0">
+                <a:pos x="csX1" y="csY1"/>
+              </a:cxn>
+              <a:cxn ang="0">
+                <a:pos x="csX2" y="csY2"/>
+              </a:cxn>
+              <a:cxn ang="0">
+                <a:pos x="csX3" y="csY3"/>
+              </a:cxn>
+              <a:cxn ang="0">
+                <a:pos x="csX4" y="csY4"/>
+              </a:cxn>
+              <a:cxn ang="0">
+                <a:pos x="csX5" y="csY5"/>
+              </a:cxn>
+              <a:cxn ang="0">
+                <a:pos x="csX6" y="csY6"/>
+              </a:cxn>
+            </a:cxnLst>
+            <a:rect l="l" t="t" r="r" b="b"/>
+            <a:pathLst>
+              <a:path w="6803136" h="3725604">
+                <a:moveTo>
+                  <a:pt x="0" y="40572"/>
+                </a:moveTo>
+                <a:lnTo>
+                  <a:pt x="2675965" y="0"/>
+                </a:lnTo>
+                <a:lnTo>
+                  <a:pt x="2675965" y="1006609"/>
+                </a:lnTo>
+                <a:lnTo>
+                  <a:pt x="6787768" y="993392"/>
+                </a:lnTo>
+                <a:cubicBezTo>
+                  <a:pt x="6790329" y="2221736"/>
+                  <a:pt x="6800575" y="2497260"/>
+                  <a:pt x="6803136" y="3725604"/>
+                </a:cubicBezTo>
+                <a:lnTo>
+                  <a:pt x="0" y="3725604"/>
+                </a:lnTo>
+                <a:lnTo>
+                  <a:pt x="0" y="40572"/>
+                </a:lnTo>
+                <a:close/>
+              </a:path>
+            </a:pathLst>
+          </a:custGeom>
+          <a:solidFill>
+            <a:srgbClr val="111E2D"/>
           </a:solidFill>
           <a:ln w="15240">
             <a:solidFill>
@@ -977,6 +941,13 @@
             <a:prstDash val="dash"/>
           </a:ln>
         </p:spPr>
+        <p:txBody>
+          <a:bodyPr/>
+          <a:lstStyle/>
+          <a:p>
+            <a:endParaRPr lang="en-US"/>
+          </a:p>
+        </p:txBody>
       </p:sp>
       <p:sp>
         <p:nvSpPr>
@@ -986,8 +957,8 @@
         </p:nvSpPr>
         <p:spPr>
           <a:xfrm>
-            <a:off x="2057400" y="1097280"/>
-            <a:ext cx="1645920" cy="256032"/>
+            <a:off x="2148840" y="1051560"/>
+            <a:ext cx="1463040" cy="228600"/>
           </a:xfrm>
           <a:prstGeom prst="rect">
             <a:avLst/>
@@ -999,7 +970,7 @@
           <a:bodyPr wrap="square" lIns="0" tIns="0" rIns="0" bIns="0" rtlCol="0" anchor="ctr"/>
           <a:lstStyle/>
           <a:p>
-            <a:pPr indent="0" marL="0">
+            <a:pPr marL="0" indent="0" algn="l">
               <a:buNone/>
             </a:pPr>
             <a:r>
@@ -1025,14 +996,14 @@
         </p:nvSpPr>
         <p:spPr>
           <a:xfrm>
-            <a:off x="182880" y="1783080"/>
-            <a:ext cx="1691640" cy="658368"/>
-          </a:xfrm>
-          <a:prstGeom prst="rect">
-            <a:avLst/>
-          </a:prstGeom>
-          <a:solidFill>
-            <a:srgbClr val="163027"/>
+            <a:off x="91440" y="2715768"/>
+            <a:ext cx="1737360" cy="658368"/>
+          </a:xfrm>
+          <a:prstGeom prst="rect">
+            <a:avLst/>
+          </a:prstGeom>
+          <a:solidFill>
+            <a:srgbClr val="122A20"/>
           </a:solidFill>
           <a:ln w="12700">
             <a:solidFill>
@@ -1040,14 +1011,14 @@
             </a:solidFill>
             <a:prstDash val="solid"/>
           </a:ln>
-          <a:effectLst>
-            <a:outerShdw sx="100000" sy="100000" kx="0" ky="0" algn="bl" rotWithShape="0" blurRad="101600" dist="38100" dir="8100000">
-              <a:srgbClr val="000000">
-                <a:alpha val="30000"/>
-              </a:srgbClr>
-            </a:outerShdw>
-          </a:effectLst>
-        </p:spPr>
+        </p:spPr>
+        <p:txBody>
+          <a:bodyPr/>
+          <a:lstStyle/>
+          <a:p>
+            <a:endParaRPr lang="en-US" dirty="0"/>
+          </a:p>
+        </p:txBody>
       </p:sp>
       <p:sp>
         <p:nvSpPr>
@@ -1057,7 +1028,7 @@
         </p:nvSpPr>
         <p:spPr>
           <a:xfrm>
-            <a:off x="182880" y="1783080"/>
+            <a:off x="112014" y="2711196"/>
             <a:ext cx="64008" cy="658368"/>
           </a:xfrm>
           <a:prstGeom prst="rect">
@@ -1073,6 +1044,13 @@
             <a:prstDash val="solid"/>
           </a:ln>
         </p:spPr>
+        <p:txBody>
+          <a:bodyPr/>
+          <a:lstStyle/>
+          <a:p>
+            <a:endParaRPr lang="en-US"/>
+          </a:p>
+        </p:txBody>
       </p:sp>
       <p:sp>
         <p:nvSpPr>
@@ -1082,8 +1060,8 @@
         </p:nvSpPr>
         <p:spPr>
           <a:xfrm>
-            <a:off x="320040" y="1874520"/>
-            <a:ext cx="1508760" cy="256032"/>
+            <a:off x="324612" y="2807208"/>
+            <a:ext cx="1572768" cy="256032"/>
           </a:xfrm>
           <a:prstGeom prst="rect">
             <a:avLst/>
@@ -1095,7 +1073,7 @@
           <a:bodyPr wrap="square" lIns="0" tIns="0" rIns="0" bIns="0" rtlCol="0" anchor="ctr"/>
           <a:lstStyle/>
           <a:p>
-            <a:pPr indent="0" marL="0">
+            <a:pPr marL="0" indent="0" algn="l">
               <a:buNone/>
             </a:pPr>
             <a:r>
@@ -1107,7 +1085,7 @@
                 <a:ea typeface="Calibri" pitchFamily="34" charset="-122"/>
                 <a:cs typeface="Calibri" pitchFamily="34" charset="-120"/>
               </a:rPr>
-              <a:t>React</a:t>
+              <a:t>User</a:t>
             </a:r>
             <a:endParaRPr lang="en-US" sz="1200" dirty="0"/>
           </a:p>
@@ -1121,8 +1099,8 @@
         </p:nvSpPr>
         <p:spPr>
           <a:xfrm>
-            <a:off x="320040" y="2103120"/>
-            <a:ext cx="1508760" cy="201168"/>
+            <a:off x="324612" y="3063240"/>
+            <a:ext cx="1572768" cy="201168"/>
           </a:xfrm>
           <a:prstGeom prst="rect">
             <a:avLst/>
@@ -1134,20 +1112,9 @@
           <a:bodyPr wrap="square" lIns="0" tIns="0" rIns="0" bIns="0" rtlCol="0" anchor="ctr"/>
           <a:lstStyle/>
           <a:p>
-            <a:pPr indent="0" marL="0">
+            <a:pPr marL="0" indent="0" algn="l">
               <a:buNone/>
             </a:pPr>
-            <a:r>
-              <a:rPr lang="en-US" sz="1000" dirty="0">
-                <a:solidFill>
-                  <a:srgbClr val="5DCAA5"/>
-                </a:solidFill>
-                <a:latin typeface="Calibri" pitchFamily="34" charset="0"/>
-                <a:ea typeface="Calibri" pitchFamily="34" charset="-122"/>
-                <a:cs typeface="Calibri" pitchFamily="34" charset="-120"/>
-              </a:rPr>
-              <a:t>Frontend app</a:t>
-            </a:r>
             <a:endParaRPr lang="en-US" sz="1000" dirty="0"/>
           </a:p>
         </p:txBody>
@@ -1160,8 +1127,8 @@
         </p:nvSpPr>
         <p:spPr>
           <a:xfrm>
-            <a:off x="2240280" y="1325880"/>
-            <a:ext cx="2286000" cy="2194560"/>
+            <a:off x="2240280" y="1280160"/>
+            <a:ext cx="2331720" cy="2240280"/>
           </a:xfrm>
           <a:prstGeom prst="rect">
             <a:avLst/>
@@ -1171,11 +1138,18 @@
           </a:solidFill>
           <a:ln w="10160">
             <a:solidFill>
-              <a:srgbClr val="534AB7"/>
+              <a:srgbClr val="7F77DD"/>
             </a:solidFill>
             <a:prstDash val="sysDash"/>
           </a:ln>
         </p:spPr>
+        <p:txBody>
+          <a:bodyPr/>
+          <a:lstStyle/>
+          <a:p>
+            <a:endParaRPr lang="en-US"/>
+          </a:p>
+        </p:txBody>
       </p:sp>
       <p:sp>
         <p:nvSpPr>
@@ -1185,8 +1159,8 @@
         </p:nvSpPr>
         <p:spPr>
           <a:xfrm>
-            <a:off x="2286000" y="1371600"/>
-            <a:ext cx="2011680" cy="228600"/>
+            <a:off x="2304288" y="1335024"/>
+            <a:ext cx="2011680" cy="219456"/>
           </a:xfrm>
           <a:prstGeom prst="rect">
             <a:avLst/>
@@ -1198,7 +1172,7 @@
           <a:bodyPr wrap="square" lIns="0" tIns="0" rIns="0" bIns="0" rtlCol="0" anchor="ctr"/>
           <a:lstStyle/>
           <a:p>
-            <a:pPr indent="0" marL="0">
+            <a:pPr marL="0" indent="0" algn="l">
               <a:buNone/>
             </a:pPr>
             <a:r>
@@ -1224,14 +1198,14 @@
         </p:nvSpPr>
         <p:spPr>
           <a:xfrm>
-            <a:off x="2377440" y="1691640"/>
-            <a:ext cx="2011680" cy="822960"/>
-          </a:xfrm>
-          <a:prstGeom prst="rect">
-            <a:avLst/>
-          </a:prstGeom>
-          <a:solidFill>
-            <a:srgbClr val="1A2A44"/>
+            <a:off x="2359152" y="1645920"/>
+            <a:ext cx="2084832" cy="804672"/>
+          </a:xfrm>
+          <a:prstGeom prst="rect">
+            <a:avLst/>
+          </a:prstGeom>
+          <a:solidFill>
+            <a:srgbClr val="0E2233"/>
           </a:solidFill>
           <a:ln w="12700">
             <a:solidFill>
@@ -1239,14 +1213,14 @@
             </a:solidFill>
             <a:prstDash val="solid"/>
           </a:ln>
-          <a:effectLst>
-            <a:outerShdw sx="100000" sy="100000" kx="0" ky="0" algn="bl" rotWithShape="0" blurRad="101600" dist="38100" dir="8100000">
-              <a:srgbClr val="000000">
-                <a:alpha val="30000"/>
-              </a:srgbClr>
-            </a:outerShdw>
-          </a:effectLst>
-        </p:spPr>
+        </p:spPr>
+        <p:txBody>
+          <a:bodyPr/>
+          <a:lstStyle/>
+          <a:p>
+            <a:endParaRPr lang="en-US"/>
+          </a:p>
+        </p:txBody>
       </p:sp>
       <p:sp>
         <p:nvSpPr>
@@ -1256,8 +1230,8 @@
         </p:nvSpPr>
         <p:spPr>
           <a:xfrm>
-            <a:off x="2377440" y="1691640"/>
-            <a:ext cx="64008" cy="822960"/>
+            <a:off x="2359152" y="1645920"/>
+            <a:ext cx="64008" cy="804672"/>
           </a:xfrm>
           <a:prstGeom prst="rect">
             <a:avLst/>
@@ -1272,6 +1246,13 @@
             <a:prstDash val="solid"/>
           </a:ln>
         </p:spPr>
+        <p:txBody>
+          <a:bodyPr/>
+          <a:lstStyle/>
+          <a:p>
+            <a:endParaRPr lang="en-US"/>
+          </a:p>
+        </p:txBody>
       </p:sp>
       <p:sp>
         <p:nvSpPr>
@@ -1281,8 +1262,8 @@
         </p:nvSpPr>
         <p:spPr>
           <a:xfrm>
-            <a:off x="2514600" y="1783080"/>
-            <a:ext cx="1828800" cy="256032"/>
+            <a:off x="2487168" y="1728216"/>
+            <a:ext cx="1920240" cy="256032"/>
           </a:xfrm>
           <a:prstGeom prst="rect">
             <a:avLst/>
@@ -1294,7 +1275,7 @@
           <a:bodyPr wrap="square" lIns="0" tIns="0" rIns="0" bIns="0" rtlCol="0" anchor="ctr"/>
           <a:lstStyle/>
           <a:p>
-            <a:pPr indent="0" marL="0">
+            <a:pPr marL="0" indent="0" algn="l">
               <a:buNone/>
             </a:pPr>
             <a:r>
@@ -1320,8 +1301,8 @@
         </p:nvSpPr>
         <p:spPr>
           <a:xfrm>
-            <a:off x="2514600" y="2011680"/>
-            <a:ext cx="1828800" cy="201168"/>
+            <a:off x="2487168" y="1984248"/>
+            <a:ext cx="1920240" cy="201168"/>
           </a:xfrm>
           <a:prstGeom prst="rect">
             <a:avLst/>
@@ -1333,7 +1314,7 @@
           <a:bodyPr wrap="square" lIns="0" tIns="0" rIns="0" bIns="0" rtlCol="0" anchor="ctr"/>
           <a:lstStyle/>
           <a:p>
-            <a:pPr indent="0" marL="0">
+            <a:pPr marL="0" indent="0" algn="l">
               <a:buNone/>
             </a:pPr>
             <a:r>
@@ -1359,14 +1340,14 @@
         </p:nvSpPr>
         <p:spPr>
           <a:xfrm>
-            <a:off x="4937760" y="1325880"/>
-            <a:ext cx="3474720" cy="685800"/>
-          </a:xfrm>
-          <a:prstGeom prst="rect">
-            <a:avLst/>
-          </a:prstGeom>
-          <a:solidFill>
-            <a:srgbClr val="1F1A0A"/>
+            <a:off x="4978908" y="2090928"/>
+            <a:ext cx="3520440" cy="658368"/>
+          </a:xfrm>
+          <a:prstGeom prst="rect">
+            <a:avLst/>
+          </a:prstGeom>
+          <a:solidFill>
+            <a:srgbClr val="1E1505"/>
           </a:solidFill>
           <a:ln w="12700">
             <a:solidFill>
@@ -1374,14 +1355,14 @@
             </a:solidFill>
             <a:prstDash val="solid"/>
           </a:ln>
-          <a:effectLst>
-            <a:outerShdw sx="100000" sy="100000" kx="0" ky="0" algn="bl" rotWithShape="0" blurRad="101600" dist="38100" dir="8100000">
-              <a:srgbClr val="000000">
-                <a:alpha val="30000"/>
-              </a:srgbClr>
-            </a:outerShdw>
-          </a:effectLst>
-        </p:spPr>
+        </p:spPr>
+        <p:txBody>
+          <a:bodyPr/>
+          <a:lstStyle/>
+          <a:p>
+            <a:endParaRPr lang="en-US"/>
+          </a:p>
+        </p:txBody>
       </p:sp>
       <p:sp>
         <p:nvSpPr>
@@ -1391,8 +1372,8 @@
         </p:nvSpPr>
         <p:spPr>
           <a:xfrm>
-            <a:off x="4937760" y="1325880"/>
-            <a:ext cx="64008" cy="685800"/>
+            <a:off x="4974336" y="2101596"/>
+            <a:ext cx="64008" cy="658368"/>
           </a:xfrm>
           <a:prstGeom prst="rect">
             <a:avLst/>
@@ -1407,6 +1388,13 @@
             <a:prstDash val="solid"/>
           </a:ln>
         </p:spPr>
+        <p:txBody>
+          <a:bodyPr/>
+          <a:lstStyle/>
+          <a:p>
+            <a:endParaRPr lang="en-US"/>
+          </a:p>
+        </p:txBody>
       </p:sp>
       <p:sp>
         <p:nvSpPr>
@@ -1416,8 +1404,8 @@
         </p:nvSpPr>
         <p:spPr>
           <a:xfrm>
-            <a:off x="5074920" y="1417320"/>
-            <a:ext cx="3291840" cy="256032"/>
+            <a:off x="5102352" y="2183892"/>
+            <a:ext cx="3355848" cy="256032"/>
           </a:xfrm>
           <a:prstGeom prst="rect">
             <a:avLst/>
@@ -1429,7 +1417,7 @@
           <a:bodyPr wrap="square" lIns="0" tIns="0" rIns="0" bIns="0" rtlCol="0" anchor="ctr"/>
           <a:lstStyle/>
           <a:p>
-            <a:pPr indent="0" marL="0">
+            <a:pPr marL="0" indent="0" algn="l">
               <a:buNone/>
             </a:pPr>
             <a:r>
@@ -1455,8 +1443,8 @@
         </p:nvSpPr>
         <p:spPr>
           <a:xfrm>
-            <a:off x="5074920" y="1645920"/>
-            <a:ext cx="3291840" cy="201168"/>
+            <a:off x="5102352" y="2439924"/>
+            <a:ext cx="3355848" cy="201168"/>
           </a:xfrm>
           <a:prstGeom prst="rect">
             <a:avLst/>
@@ -1468,7 +1456,7 @@
           <a:bodyPr wrap="square" lIns="0" tIns="0" rIns="0" bIns="0" rtlCol="0" anchor="ctr"/>
           <a:lstStyle/>
           <a:p>
-            <a:pPr indent="0" marL="0">
+            <a:pPr marL="0" indent="0" algn="l">
               <a:buNone/>
             </a:pPr>
             <a:r>
@@ -1494,14 +1482,14 @@
         </p:nvSpPr>
         <p:spPr>
           <a:xfrm>
-            <a:off x="4937760" y="2240280"/>
-            <a:ext cx="3474720" cy="685800"/>
-          </a:xfrm>
-          <a:prstGeom prst="rect">
-            <a:avLst/>
-          </a:prstGeom>
-          <a:solidFill>
-            <a:srgbClr val="1A0F14"/>
+            <a:off x="4960620" y="1137365"/>
+            <a:ext cx="3520440" cy="658368"/>
+          </a:xfrm>
+          <a:prstGeom prst="rect">
+            <a:avLst/>
+          </a:prstGeom>
+          <a:solidFill>
+            <a:srgbClr val="1A0D14"/>
           </a:solidFill>
           <a:ln w="12700">
             <a:solidFill>
@@ -1509,14 +1497,14 @@
             </a:solidFill>
             <a:prstDash val="solid"/>
           </a:ln>
-          <a:effectLst>
-            <a:outerShdw sx="100000" sy="100000" kx="0" ky="0" algn="bl" rotWithShape="0" blurRad="101600" dist="38100" dir="8100000">
-              <a:srgbClr val="000000">
-                <a:alpha val="30000"/>
-              </a:srgbClr>
-            </a:outerShdw>
-          </a:effectLst>
-        </p:spPr>
+        </p:spPr>
+        <p:txBody>
+          <a:bodyPr/>
+          <a:lstStyle/>
+          <a:p>
+            <a:endParaRPr lang="en-US"/>
+          </a:p>
+        </p:txBody>
       </p:sp>
       <p:sp>
         <p:nvSpPr>
@@ -1526,8 +1514,8 @@
         </p:nvSpPr>
         <p:spPr>
           <a:xfrm>
-            <a:off x="4937760" y="2240280"/>
-            <a:ext cx="64008" cy="685800"/>
+            <a:off x="4963386" y="1133856"/>
+            <a:ext cx="64008" cy="658368"/>
           </a:xfrm>
           <a:prstGeom prst="rect">
             <a:avLst/>
@@ -1542,6 +1530,13 @@
             <a:prstDash val="solid"/>
           </a:ln>
         </p:spPr>
+        <p:txBody>
+          <a:bodyPr/>
+          <a:lstStyle/>
+          <a:p>
+            <a:endParaRPr lang="en-US"/>
+          </a:p>
+        </p:txBody>
       </p:sp>
       <p:sp>
         <p:nvSpPr>
@@ -1551,8 +1546,8 @@
         </p:nvSpPr>
         <p:spPr>
           <a:xfrm>
-            <a:off x="5074920" y="2331720"/>
-            <a:ext cx="3291840" cy="256032"/>
+            <a:off x="5088636" y="1365965"/>
+            <a:ext cx="3355848" cy="256032"/>
           </a:xfrm>
           <a:prstGeom prst="rect">
             <a:avLst/>
@@ -1564,7 +1559,7 @@
           <a:bodyPr wrap="square" lIns="0" tIns="0" rIns="0" bIns="0" rtlCol="0" anchor="ctr"/>
           <a:lstStyle/>
           <a:p>
-            <a:pPr indent="0" marL="0">
+            <a:pPr marL="0" indent="0" algn="l">
               <a:buNone/>
             </a:pPr>
             <a:r>
@@ -1590,8 +1585,8 @@
         </p:nvSpPr>
         <p:spPr>
           <a:xfrm>
-            <a:off x="5074920" y="2560320"/>
-            <a:ext cx="3291840" cy="201168"/>
+            <a:off x="5088636" y="1621997"/>
+            <a:ext cx="3355848" cy="201168"/>
           </a:xfrm>
           <a:prstGeom prst="rect">
             <a:avLst/>
@@ -1603,7 +1598,7 @@
           <a:bodyPr wrap="square" lIns="0" tIns="0" rIns="0" bIns="0" rtlCol="0" anchor="ctr"/>
           <a:lstStyle/>
           <a:p>
-            <a:pPr indent="0" marL="0">
+            <a:pPr marL="0" indent="0" algn="l">
               <a:buNone/>
             </a:pPr>
             <a:r>
@@ -1629,8 +1624,8 @@
         </p:nvSpPr>
         <p:spPr>
           <a:xfrm>
-            <a:off x="4937760" y="3154680"/>
-            <a:ext cx="3474720" cy="685800"/>
+            <a:off x="4983480" y="3054096"/>
+            <a:ext cx="3520440" cy="658368"/>
           </a:xfrm>
           <a:prstGeom prst="rect">
             <a:avLst/>
@@ -1644,14 +1639,14 @@
             </a:solidFill>
             <a:prstDash val="solid"/>
           </a:ln>
-          <a:effectLst>
-            <a:outerShdw sx="100000" sy="100000" kx="0" ky="0" algn="bl" rotWithShape="0" blurRad="101600" dist="38100" dir="8100000">
-              <a:srgbClr val="000000">
-                <a:alpha val="30000"/>
-              </a:srgbClr>
-            </a:outerShdw>
-          </a:effectLst>
-        </p:spPr>
+        </p:spPr>
+        <p:txBody>
+          <a:bodyPr/>
+          <a:lstStyle/>
+          <a:p>
+            <a:endParaRPr lang="en-US"/>
+          </a:p>
+        </p:txBody>
       </p:sp>
       <p:sp>
         <p:nvSpPr>
@@ -1661,8 +1656,8 @@
         </p:nvSpPr>
         <p:spPr>
           <a:xfrm>
-            <a:off x="4937760" y="3154680"/>
-            <a:ext cx="64008" cy="685800"/>
+            <a:off x="4983480" y="3054096"/>
+            <a:ext cx="64008" cy="658368"/>
           </a:xfrm>
           <a:prstGeom prst="rect">
             <a:avLst/>
@@ -1677,6 +1672,13 @@
             <a:prstDash val="solid"/>
           </a:ln>
         </p:spPr>
+        <p:txBody>
+          <a:bodyPr/>
+          <a:lstStyle/>
+          <a:p>
+            <a:endParaRPr lang="en-US"/>
+          </a:p>
+        </p:txBody>
       </p:sp>
       <p:sp>
         <p:nvSpPr>
@@ -1686,8 +1688,8 @@
         </p:nvSpPr>
         <p:spPr>
           <a:xfrm>
-            <a:off x="5074920" y="3246120"/>
-            <a:ext cx="3291840" cy="256032"/>
+            <a:off x="5111496" y="3136392"/>
+            <a:ext cx="3355848" cy="256032"/>
           </a:xfrm>
           <a:prstGeom prst="rect">
             <a:avLst/>
@@ -1699,7 +1701,7 @@
           <a:bodyPr wrap="square" lIns="0" tIns="0" rIns="0" bIns="0" rtlCol="0" anchor="ctr"/>
           <a:lstStyle/>
           <a:p>
-            <a:pPr indent="0" marL="0">
+            <a:pPr marL="0" indent="0" algn="l">
               <a:buNone/>
             </a:pPr>
             <a:r>
@@ -1725,8 +1727,8 @@
         </p:nvSpPr>
         <p:spPr>
           <a:xfrm>
-            <a:off x="5074920" y="3474720"/>
-            <a:ext cx="3291840" cy="201168"/>
+            <a:off x="5111496" y="3392424"/>
+            <a:ext cx="3355848" cy="201168"/>
           </a:xfrm>
           <a:prstGeom prst="rect">
             <a:avLst/>
@@ -1738,7 +1740,7 @@
           <a:bodyPr wrap="square" lIns="0" tIns="0" rIns="0" bIns="0" rtlCol="0" anchor="ctr"/>
           <a:lstStyle/>
           <a:p>
-            <a:pPr indent="0" marL="0">
+            <a:pPr marL="0" indent="0" algn="l">
               <a:buNone/>
             </a:pPr>
             <a:r>
@@ -1764,14 +1766,14 @@
         </p:nvSpPr>
         <p:spPr>
           <a:xfrm>
-            <a:off x="2240280" y="3977640"/>
-            <a:ext cx="6492240" cy="502920"/>
-          </a:xfrm>
-          <a:prstGeom prst="rect">
-            <a:avLst/>
-          </a:prstGeom>
-          <a:solidFill>
-            <a:srgbClr val="0C1520"/>
+            <a:off x="2240280" y="3931920"/>
+            <a:ext cx="6263640" cy="475488"/>
+          </a:xfrm>
+          <a:prstGeom prst="rect">
+            <a:avLst/>
+          </a:prstGeom>
+          <a:solidFill>
+            <a:srgbClr val="0A1520"/>
           </a:solidFill>
           <a:ln w="7620">
             <a:solidFill>
@@ -1780,6 +1782,13 @@
             <a:prstDash val="dash"/>
           </a:ln>
         </p:spPr>
+        <p:txBody>
+          <a:bodyPr/>
+          <a:lstStyle/>
+          <a:p>
+            <a:endParaRPr lang="en-US"/>
+          </a:p>
+        </p:txBody>
       </p:sp>
       <p:sp>
         <p:nvSpPr>
@@ -1789,8 +1798,8 @@
         </p:nvSpPr>
         <p:spPr>
           <a:xfrm>
-            <a:off x="2331720" y="4023360"/>
-            <a:ext cx="6309360" cy="320040"/>
+            <a:off x="2286000" y="3977640"/>
+            <a:ext cx="6172200" cy="320040"/>
           </a:xfrm>
           <a:prstGeom prst="rect">
             <a:avLst/>
@@ -1802,13 +1811,13 @@
           <a:bodyPr wrap="square" lIns="0" tIns="0" rIns="0" bIns="0" rtlCol="0" anchor="ctr"/>
           <a:lstStyle/>
           <a:p>
-            <a:pPr algn="ctr" indent="0" marL="0">
+            <a:pPr marL="0" indent="0" algn="ctr">
               <a:buNone/>
             </a:pPr>
             <a:r>
               <a:rPr lang="en-US" sz="1100" i="1" dirty="0">
                 <a:solidFill>
-                  <a:srgbClr val="6B8BAE"/>
+                  <a:srgbClr val="5A7A9A"/>
                 </a:solidFill>
                 <a:latin typeface="Calibri" pitchFamily="34" charset="0"/>
                 <a:ea typeface="Calibri" pitchFamily="34" charset="-122"/>
@@ -1822,38 +1831,14 @@
       </p:sp>
       <p:sp>
         <p:nvSpPr>
-          <p:cNvPr id="30" name="Shape 28"/>
-          <p:cNvSpPr/>
-          <p:nvPr/>
-        </p:nvSpPr>
-        <p:spPr>
-          <a:xfrm>
-            <a:off x="1874520" y="2112264"/>
-            <a:ext cx="365760" cy="0"/>
-          </a:xfrm>
-          <a:prstGeom prst="line">
-            <a:avLst/>
-          </a:prstGeom>
-          <a:noFill/>
-          <a:ln w="19050">
-            <a:solidFill>
-              <a:srgbClr val="1D9E75"/>
-            </a:solidFill>
-            <a:prstDash val="solid"/>
-            <a:tailEnd type="open"/>
-          </a:ln>
-        </p:spPr>
-      </p:sp>
-      <p:sp>
-        <p:nvSpPr>
-          <p:cNvPr id="31" name="Text 29"/>
-          <p:cNvSpPr/>
-          <p:nvPr/>
-        </p:nvSpPr>
-        <p:spPr>
-          <a:xfrm>
-            <a:off x="1828800" y="1938528"/>
-            <a:ext cx="502920" cy="201168"/>
+          <p:cNvPr id="30" name="Text 28"/>
+          <p:cNvSpPr/>
+          <p:nvPr/>
+        </p:nvSpPr>
+        <p:spPr>
+          <a:xfrm>
+            <a:off x="1796796" y="2953512"/>
+            <a:ext cx="457200" cy="201168"/>
           </a:xfrm>
           <a:prstGeom prst="rect">
             <a:avLst/>
@@ -1865,11 +1850,11 @@
           <a:bodyPr wrap="square" lIns="0" tIns="0" rIns="0" bIns="0" rtlCol="0" anchor="ctr"/>
           <a:lstStyle/>
           <a:p>
-            <a:pPr algn="ctr" indent="0" marL="0">
+            <a:pPr marL="0" indent="0" algn="ctr">
               <a:buNone/>
             </a:pPr>
             <a:r>
-              <a:rPr lang="en-US" sz="800" dirty="0">
+              <a:rPr lang="en-US" sz="900" dirty="0">
                 <a:solidFill>
                   <a:srgbClr val="1D9E75"/>
                 </a:solidFill>
@@ -1877,46 +1862,22 @@
                 <a:ea typeface="Calibri" pitchFamily="34" charset="-122"/>
                 <a:cs typeface="Calibri" pitchFamily="34" charset="-120"/>
               </a:rPr>
-              <a:t>HTTP</a:t>
+              <a:t>HTTP →</a:t>
             </a:r>
-            <a:endParaRPr lang="en-US" sz="800" dirty="0"/>
-          </a:p>
-        </p:txBody>
-      </p:sp>
-      <p:sp>
-        <p:nvSpPr>
-          <p:cNvPr id="32" name="Shape 30"/>
-          <p:cNvSpPr/>
-          <p:nvPr/>
-        </p:nvSpPr>
-        <p:spPr>
-          <a:xfrm>
-            <a:off x="4389120" y="1664208"/>
-            <a:ext cx="548640" cy="0"/>
-          </a:xfrm>
-          <a:prstGeom prst="line">
-            <a:avLst/>
-          </a:prstGeom>
-          <a:noFill/>
-          <a:ln w="19050">
-            <a:solidFill>
-              <a:srgbClr val="EF9F27"/>
-            </a:solidFill>
-            <a:prstDash val="solid"/>
-            <a:tailEnd type="open"/>
-          </a:ln>
-        </p:spPr>
-      </p:sp>
-      <p:sp>
-        <p:nvSpPr>
-          <p:cNvPr id="33" name="Text 31"/>
-          <p:cNvSpPr/>
-          <p:nvPr/>
-        </p:nvSpPr>
-        <p:spPr>
-          <a:xfrm>
-            <a:off x="4407408" y="1508760"/>
-            <a:ext cx="502920" cy="182880"/>
+            <a:endParaRPr lang="en-US" sz="900" dirty="0"/>
+          </a:p>
+        </p:txBody>
+      </p:sp>
+      <p:sp>
+        <p:nvSpPr>
+          <p:cNvPr id="31" name="Text 29"/>
+          <p:cNvSpPr/>
+          <p:nvPr/>
+        </p:nvSpPr>
+        <p:spPr>
+          <a:xfrm>
+            <a:off x="4304538" y="2524898"/>
+            <a:ext cx="640080" cy="182880"/>
           </a:xfrm>
           <a:prstGeom prst="rect">
             <a:avLst/>
@@ -1928,11 +1889,11 @@
           <a:bodyPr wrap="square" lIns="0" tIns="0" rIns="0" bIns="0" rtlCol="0" anchor="ctr"/>
           <a:lstStyle/>
           <a:p>
-            <a:pPr algn="ctr" indent="0" marL="0">
+            <a:pPr marL="0" indent="0" algn="ctr">
               <a:buNone/>
             </a:pPr>
             <a:r>
-              <a:rPr lang="en-US" sz="800" dirty="0">
+              <a:rPr lang="en-US" sz="900" dirty="0">
                 <a:solidFill>
                   <a:srgbClr val="EF9F27"/>
                 </a:solidFill>
@@ -1940,46 +1901,22 @@
                 <a:ea typeface="Calibri" pitchFamily="34" charset="-122"/>
                 <a:cs typeface="Calibri" pitchFamily="34" charset="-120"/>
               </a:rPr>
-              <a:t>query</a:t>
+              <a:t>query →</a:t>
             </a:r>
-            <a:endParaRPr lang="en-US" sz="800" dirty="0"/>
-          </a:p>
-        </p:txBody>
-      </p:sp>
-      <p:sp>
-        <p:nvSpPr>
-          <p:cNvPr id="34" name="Shape 32"/>
-          <p:cNvSpPr/>
-          <p:nvPr/>
-        </p:nvSpPr>
-        <p:spPr>
-          <a:xfrm>
-            <a:off x="4389120" y="2578608"/>
-            <a:ext cx="548640" cy="0"/>
-          </a:xfrm>
-          <a:prstGeom prst="line">
-            <a:avLst/>
-          </a:prstGeom>
-          <a:noFill/>
-          <a:ln w="19050">
-            <a:solidFill>
-              <a:srgbClr val="D4537E"/>
-            </a:solidFill>
-            <a:prstDash val="solid"/>
-            <a:tailEnd type="open"/>
-          </a:ln>
-        </p:spPr>
-      </p:sp>
-      <p:sp>
-        <p:nvSpPr>
-          <p:cNvPr id="35" name="Text 33"/>
-          <p:cNvSpPr/>
-          <p:nvPr/>
-        </p:nvSpPr>
-        <p:spPr>
-          <a:xfrm>
-            <a:off x="4407408" y="2423160"/>
-            <a:ext cx="502920" cy="182880"/>
+            <a:endParaRPr lang="en-US" sz="900" dirty="0"/>
+          </a:p>
+        </p:txBody>
+      </p:sp>
+      <p:sp>
+        <p:nvSpPr>
+          <p:cNvPr id="32" name="Text 30"/>
+          <p:cNvSpPr/>
+          <p:nvPr/>
+        </p:nvSpPr>
+        <p:spPr>
+          <a:xfrm>
+            <a:off x="4315968" y="1353312"/>
+            <a:ext cx="658368" cy="182880"/>
           </a:xfrm>
           <a:prstGeom prst="rect">
             <a:avLst/>
@@ -1991,11 +1928,11 @@
           <a:bodyPr wrap="square" lIns="0" tIns="0" rIns="0" bIns="0" rtlCol="0" anchor="ctr"/>
           <a:lstStyle/>
           <a:p>
-            <a:pPr algn="ctr" indent="0" marL="0">
+            <a:pPr marL="0" indent="0" algn="ctr">
               <a:buNone/>
             </a:pPr>
             <a:r>
-              <a:rPr lang="en-US" sz="800" dirty="0">
+              <a:rPr lang="en-US" sz="900" dirty="0">
                 <a:solidFill>
                   <a:srgbClr val="D4537E"/>
                 </a:solidFill>
@@ -2003,7 +1940,46 @@
                 <a:ea typeface="Calibri" pitchFamily="34" charset="-122"/>
                 <a:cs typeface="Calibri" pitchFamily="34" charset="-120"/>
               </a:rPr>
-              <a:t>upload</a:t>
+              <a:t>upload →</a:t>
+            </a:r>
+            <a:endParaRPr lang="en-US" sz="900" dirty="0"/>
+          </a:p>
+        </p:txBody>
+      </p:sp>
+      <p:sp>
+        <p:nvSpPr>
+          <p:cNvPr id="33" name="Text 31"/>
+          <p:cNvSpPr/>
+          <p:nvPr/>
+        </p:nvSpPr>
+        <p:spPr>
+          <a:xfrm>
+            <a:off x="4846320" y="2907792"/>
+            <a:ext cx="1188720" cy="182880"/>
+          </a:xfrm>
+          <a:prstGeom prst="rect">
+            <a:avLst/>
+          </a:prstGeom>
+          <a:noFill/>
+          <a:ln/>
+        </p:spPr>
+        <p:txBody>
+          <a:bodyPr wrap="square" lIns="0" tIns="0" rIns="0" bIns="0" rtlCol="0" anchor="ctr"/>
+          <a:lstStyle/>
+          <a:p>
+            <a:pPr marL="0" indent="0" algn="l">
+              <a:buNone/>
+            </a:pPr>
+            <a:r>
+              <a:rPr lang="en-US" sz="800" dirty="0">
+                <a:solidFill>
+                  <a:srgbClr val="888780"/>
+                </a:solidFill>
+                <a:latin typeface="Calibri" pitchFamily="34" charset="0"/>
+                <a:ea typeface="Calibri" pitchFamily="34" charset="-122"/>
+                <a:cs typeface="Calibri" pitchFamily="34" charset="-120"/>
+              </a:rPr>
+              <a:t>grants access ↗</a:t>
             </a:r>
             <a:endParaRPr lang="en-US" sz="800" dirty="0"/>
           </a:p>
@@ -2011,38 +1987,14 @@
       </p:sp>
       <p:sp>
         <p:nvSpPr>
-          <p:cNvPr id="36" name="Shape 34"/>
-          <p:cNvSpPr/>
-          <p:nvPr/>
-        </p:nvSpPr>
-        <p:spPr>
-          <a:xfrm>
-            <a:off x="4937760" y="3154680"/>
-            <a:ext cx="0" cy="-228600"/>
-          </a:xfrm>
-          <a:prstGeom prst="line">
-            <a:avLst/>
-          </a:prstGeom>
-          <a:noFill/>
-          <a:ln w="12700">
-            <a:solidFill>
-              <a:srgbClr val="888780"/>
-            </a:solidFill>
-            <a:prstDash val="dash"/>
-            <a:tailEnd type="open"/>
-          </a:ln>
-        </p:spPr>
-      </p:sp>
-      <p:sp>
-        <p:nvSpPr>
-          <p:cNvPr id="37" name="Shape 35"/>
-          <p:cNvSpPr/>
-          <p:nvPr/>
-        </p:nvSpPr>
-        <p:spPr>
-          <a:xfrm>
-            <a:off x="182880" y="4645152"/>
-            <a:ext cx="1645920" cy="237744"/>
+          <p:cNvPr id="34" name="Shape 32"/>
+          <p:cNvSpPr/>
+          <p:nvPr/>
+        </p:nvSpPr>
+        <p:spPr>
+          <a:xfrm>
+            <a:off x="137160" y="4663440"/>
+            <a:ext cx="1645920" cy="228600"/>
           </a:xfrm>
           <a:prstGeom prst="rect">
             <a:avLst/>
@@ -2050,24 +2002,31 @@
           <a:solidFill>
             <a:srgbClr val="0D1B2A"/>
           </a:solidFill>
-          <a:ln w="7620">
+          <a:ln w="8890">
             <a:solidFill>
               <a:srgbClr val="AFA9EC"/>
             </a:solidFill>
             <a:prstDash val="solid"/>
           </a:ln>
         </p:spPr>
-      </p:sp>
-      <p:sp>
-        <p:nvSpPr>
-          <p:cNvPr id="38" name="Text 36"/>
-          <p:cNvSpPr/>
-          <p:nvPr/>
-        </p:nvSpPr>
-        <p:spPr>
-          <a:xfrm>
-            <a:off x="201168" y="4663440"/>
-            <a:ext cx="1609344" cy="201168"/>
+        <p:txBody>
+          <a:bodyPr/>
+          <a:lstStyle/>
+          <a:p>
+            <a:endParaRPr lang="en-US"/>
+          </a:p>
+        </p:txBody>
+      </p:sp>
+      <p:sp>
+        <p:nvSpPr>
+          <p:cNvPr id="35" name="Text 33"/>
+          <p:cNvSpPr/>
+          <p:nvPr/>
+        </p:nvSpPr>
+        <p:spPr>
+          <a:xfrm>
+            <a:off x="155448" y="4681728"/>
+            <a:ext cx="1609344" cy="192024"/>
           </a:xfrm>
           <a:prstGeom prst="rect">
             <a:avLst/>
@@ -2079,7 +2038,7 @@
           <a:bodyPr wrap="square" lIns="0" tIns="0" rIns="0" bIns="0" rtlCol="0" anchor="ctr"/>
           <a:lstStyle/>
           <a:p>
-            <a:pPr algn="ctr" indent="0" marL="0">
+            <a:pPr marL="0" indent="0" algn="ctr">
               <a:buNone/>
             </a:pPr>
             <a:r>
@@ -2091,7 +2050,7 @@
                 <a:ea typeface="Calibri" pitchFamily="34" charset="-122"/>
                 <a:cs typeface="Calibri" pitchFamily="34" charset="-120"/>
               </a:rPr>
-              <a:t>Wk 2-3: EC2</a:t>
+              <a:t>EC2</a:t>
             </a:r>
             <a:endParaRPr lang="en-US" sz="900" dirty="0"/>
           </a:p>
@@ -2099,14 +2058,14 @@
       </p:sp>
       <p:sp>
         <p:nvSpPr>
-          <p:cNvPr id="39" name="Shape 37"/>
-          <p:cNvSpPr/>
-          <p:nvPr/>
-        </p:nvSpPr>
-        <p:spPr>
-          <a:xfrm>
-            <a:off x="1965960" y="4645152"/>
-            <a:ext cx="1645920" cy="237744"/>
+          <p:cNvPr id="36" name="Shape 34"/>
+          <p:cNvSpPr/>
+          <p:nvPr/>
+        </p:nvSpPr>
+        <p:spPr>
+          <a:xfrm>
+            <a:off x="1911096" y="4663440"/>
+            <a:ext cx="1645920" cy="228600"/>
           </a:xfrm>
           <a:prstGeom prst="rect">
             <a:avLst/>
@@ -2114,24 +2073,31 @@
           <a:solidFill>
             <a:srgbClr val="0D1B2A"/>
           </a:solidFill>
-          <a:ln w="7620">
+          <a:ln w="8890">
             <a:solidFill>
               <a:srgbClr val="5DCAA5"/>
             </a:solidFill>
             <a:prstDash val="solid"/>
           </a:ln>
         </p:spPr>
-      </p:sp>
-      <p:sp>
-        <p:nvSpPr>
-          <p:cNvPr id="40" name="Text 38"/>
-          <p:cNvSpPr/>
-          <p:nvPr/>
-        </p:nvSpPr>
-        <p:spPr>
-          <a:xfrm>
-            <a:off x="1984248" y="4663440"/>
-            <a:ext cx="1609344" cy="201168"/>
+        <p:txBody>
+          <a:bodyPr/>
+          <a:lstStyle/>
+          <a:p>
+            <a:endParaRPr lang="en-US"/>
+          </a:p>
+        </p:txBody>
+      </p:sp>
+      <p:sp>
+        <p:nvSpPr>
+          <p:cNvPr id="37" name="Text 35"/>
+          <p:cNvSpPr/>
+          <p:nvPr/>
+        </p:nvSpPr>
+        <p:spPr>
+          <a:xfrm>
+            <a:off x="1929384" y="4681728"/>
+            <a:ext cx="1609344" cy="192024"/>
           </a:xfrm>
           <a:prstGeom prst="rect">
             <a:avLst/>
@@ -2143,7 +2109,7 @@
           <a:bodyPr wrap="square" lIns="0" tIns="0" rIns="0" bIns="0" rtlCol="0" anchor="ctr"/>
           <a:lstStyle/>
           <a:p>
-            <a:pPr algn="ctr" indent="0" marL="0">
+            <a:pPr marL="0" indent="0" algn="ctr">
               <a:buNone/>
             </a:pPr>
             <a:r>
@@ -2155,7 +2121,7 @@
                 <a:ea typeface="Calibri" pitchFamily="34" charset="-122"/>
                 <a:cs typeface="Calibri" pitchFamily="34" charset="-120"/>
               </a:rPr>
-              <a:t>Wk 4: Docker</a:t>
+              <a:t>Docker</a:t>
             </a:r>
             <a:endParaRPr lang="en-US" sz="900" dirty="0"/>
           </a:p>
@@ -2163,14 +2129,14 @@
       </p:sp>
       <p:sp>
         <p:nvSpPr>
-          <p:cNvPr id="41" name="Shape 39"/>
-          <p:cNvSpPr/>
-          <p:nvPr/>
-        </p:nvSpPr>
-        <p:spPr>
-          <a:xfrm>
-            <a:off x="3749040" y="4645152"/>
-            <a:ext cx="1645920" cy="237744"/>
+          <p:cNvPr id="38" name="Shape 36"/>
+          <p:cNvSpPr/>
+          <p:nvPr/>
+        </p:nvSpPr>
+        <p:spPr>
+          <a:xfrm>
+            <a:off x="3685032" y="4663440"/>
+            <a:ext cx="1645920" cy="228600"/>
           </a:xfrm>
           <a:prstGeom prst="rect">
             <a:avLst/>
@@ -2178,24 +2144,31 @@
           <a:solidFill>
             <a:srgbClr val="0D1B2A"/>
           </a:solidFill>
-          <a:ln w="7620">
+          <a:ln w="8890">
             <a:solidFill>
               <a:srgbClr val="FAC775"/>
             </a:solidFill>
             <a:prstDash val="solid"/>
           </a:ln>
         </p:spPr>
-      </p:sp>
-      <p:sp>
-        <p:nvSpPr>
-          <p:cNvPr id="42" name="Text 40"/>
-          <p:cNvSpPr/>
-          <p:nvPr/>
-        </p:nvSpPr>
-        <p:spPr>
-          <a:xfrm>
-            <a:off x="3767328" y="4663440"/>
-            <a:ext cx="1609344" cy="201168"/>
+        <p:txBody>
+          <a:bodyPr/>
+          <a:lstStyle/>
+          <a:p>
+            <a:endParaRPr lang="en-US"/>
+          </a:p>
+        </p:txBody>
+      </p:sp>
+      <p:sp>
+        <p:nvSpPr>
+          <p:cNvPr id="39" name="Text 37"/>
+          <p:cNvSpPr/>
+          <p:nvPr/>
+        </p:nvSpPr>
+        <p:spPr>
+          <a:xfrm>
+            <a:off x="3703320" y="4681728"/>
+            <a:ext cx="1609344" cy="192024"/>
           </a:xfrm>
           <a:prstGeom prst="rect">
             <a:avLst/>
@@ -2207,7 +2180,7 @@
           <a:bodyPr wrap="square" lIns="0" tIns="0" rIns="0" bIns="0" rtlCol="0" anchor="ctr"/>
           <a:lstStyle/>
           <a:p>
-            <a:pPr algn="ctr" indent="0" marL="0">
+            <a:pPr marL="0" indent="0" algn="ctr">
               <a:buNone/>
             </a:pPr>
             <a:r>
@@ -2219,7 +2192,7 @@
                 <a:ea typeface="Calibri" pitchFamily="34" charset="-122"/>
                 <a:cs typeface="Calibri" pitchFamily="34" charset="-120"/>
               </a:rPr>
-              <a:t>Wk 5: RDS</a:t>
+              <a:t>RDS</a:t>
             </a:r>
             <a:endParaRPr lang="en-US" sz="900" dirty="0"/>
           </a:p>
@@ -2227,14 +2200,14 @@
       </p:sp>
       <p:sp>
         <p:nvSpPr>
-          <p:cNvPr id="43" name="Shape 41"/>
-          <p:cNvSpPr/>
-          <p:nvPr/>
-        </p:nvSpPr>
-        <p:spPr>
-          <a:xfrm>
-            <a:off x="5532120" y="4645152"/>
-            <a:ext cx="1645920" cy="237744"/>
+          <p:cNvPr id="40" name="Shape 38"/>
+          <p:cNvSpPr/>
+          <p:nvPr/>
+        </p:nvSpPr>
+        <p:spPr>
+          <a:xfrm>
+            <a:off x="5458968" y="4663440"/>
+            <a:ext cx="1645920" cy="228600"/>
           </a:xfrm>
           <a:prstGeom prst="rect">
             <a:avLst/>
@@ -2242,24 +2215,31 @@
           <a:solidFill>
             <a:srgbClr val="0D1B2A"/>
           </a:solidFill>
-          <a:ln w="7620">
+          <a:ln w="8890">
             <a:solidFill>
               <a:srgbClr val="6B8BAE"/>
             </a:solidFill>
             <a:prstDash val="solid"/>
           </a:ln>
         </p:spPr>
-      </p:sp>
-      <p:sp>
-        <p:nvSpPr>
-          <p:cNvPr id="44" name="Text 42"/>
-          <p:cNvSpPr/>
-          <p:nvPr/>
-        </p:nvSpPr>
-        <p:spPr>
-          <a:xfrm>
-            <a:off x="5550408" y="4663440"/>
-            <a:ext cx="1609344" cy="201168"/>
+        <p:txBody>
+          <a:bodyPr/>
+          <a:lstStyle/>
+          <a:p>
+            <a:endParaRPr lang="en-US"/>
+          </a:p>
+        </p:txBody>
+      </p:sp>
+      <p:sp>
+        <p:nvSpPr>
+          <p:cNvPr id="41" name="Text 39"/>
+          <p:cNvSpPr/>
+          <p:nvPr/>
+        </p:nvSpPr>
+        <p:spPr>
+          <a:xfrm>
+            <a:off x="5477256" y="4681728"/>
+            <a:ext cx="1609344" cy="192024"/>
           </a:xfrm>
           <a:prstGeom prst="rect">
             <a:avLst/>
@@ -2271,7 +2251,7 @@
           <a:bodyPr wrap="square" lIns="0" tIns="0" rIns="0" bIns="0" rtlCol="0" anchor="ctr"/>
           <a:lstStyle/>
           <a:p>
-            <a:pPr algn="ctr" indent="0" marL="0">
+            <a:pPr marL="0" indent="0" algn="ctr">
               <a:buNone/>
             </a:pPr>
             <a:r>
@@ -2283,7 +2263,7 @@
                 <a:ea typeface="Calibri" pitchFamily="34" charset="-122"/>
                 <a:cs typeface="Calibri" pitchFamily="34" charset="-120"/>
               </a:rPr>
-              <a:t>Wk 6: Terraform</a:t>
+              <a:t>Terraform</a:t>
             </a:r>
             <a:endParaRPr lang="en-US" sz="900" dirty="0"/>
           </a:p>
@@ -2291,14 +2271,14 @@
       </p:sp>
       <p:sp>
         <p:nvSpPr>
-          <p:cNvPr id="45" name="Shape 43"/>
-          <p:cNvSpPr/>
-          <p:nvPr/>
-        </p:nvSpPr>
-        <p:spPr>
-          <a:xfrm>
-            <a:off x="7315200" y="4645152"/>
-            <a:ext cx="1645920" cy="237744"/>
+          <p:cNvPr id="42" name="Shape 40"/>
+          <p:cNvSpPr/>
+          <p:nvPr/>
+        </p:nvSpPr>
+        <p:spPr>
+          <a:xfrm>
+            <a:off x="7232904" y="4663440"/>
+            <a:ext cx="1645920" cy="228600"/>
           </a:xfrm>
           <a:prstGeom prst="rect">
             <a:avLst/>
@@ -2306,24 +2286,31 @@
           <a:solidFill>
             <a:srgbClr val="0D1B2A"/>
           </a:solidFill>
-          <a:ln w="7620">
+          <a:ln w="8890">
             <a:solidFill>
               <a:srgbClr val="F4C0D1"/>
             </a:solidFill>
             <a:prstDash val="solid"/>
           </a:ln>
         </p:spPr>
-      </p:sp>
-      <p:sp>
-        <p:nvSpPr>
-          <p:cNvPr id="46" name="Text 44"/>
-          <p:cNvSpPr/>
-          <p:nvPr/>
-        </p:nvSpPr>
-        <p:spPr>
-          <a:xfrm>
-            <a:off x="7333488" y="4663440"/>
-            <a:ext cx="1609344" cy="201168"/>
+        <p:txBody>
+          <a:bodyPr/>
+          <a:lstStyle/>
+          <a:p>
+            <a:endParaRPr lang="en-US"/>
+          </a:p>
+        </p:txBody>
+      </p:sp>
+      <p:sp>
+        <p:nvSpPr>
+          <p:cNvPr id="43" name="Text 41"/>
+          <p:cNvSpPr/>
+          <p:nvPr/>
+        </p:nvSpPr>
+        <p:spPr>
+          <a:xfrm>
+            <a:off x="7251192" y="4681728"/>
+            <a:ext cx="1609344" cy="192024"/>
           </a:xfrm>
           <a:prstGeom prst="rect">
             <a:avLst/>
@@ -2335,7 +2322,7 @@
           <a:bodyPr wrap="square" lIns="0" tIns="0" rIns="0" bIns="0" rtlCol="0" anchor="ctr"/>
           <a:lstStyle/>
           <a:p>
-            <a:pPr algn="ctr" indent="0" marL="0">
+            <a:pPr marL="0" indent="0" algn="ctr">
               <a:buNone/>
             </a:pPr>
             <a:r>
@@ -2347,7 +2334,7 @@
                 <a:ea typeface="Calibri" pitchFamily="34" charset="-122"/>
                 <a:cs typeface="Calibri" pitchFamily="34" charset="-120"/>
               </a:rPr>
-              <a:t>Wk 7: S3 + IAM</a:t>
+              <a:t>S3 + IAM</a:t>
             </a:r>
             <a:endParaRPr lang="en-US" sz="900" dirty="0"/>
           </a:p>
@@ -2654,4 +2641,319 @@
     </a:ext>
   </a:extLst>
 </a:theme>
+</file>
+
+<file path=ppt/theme/theme2.xml><?xml version="1.0" encoding="utf-8"?>
+<a:theme xmlns:a="http://schemas.openxmlformats.org/drawingml/2006/main" name="Office Theme">
+  <a:themeElements>
+    <a:clrScheme name="Office">
+      <a:dk1>
+        <a:sysClr val="windowText" lastClr="000000"/>
+      </a:dk1>
+      <a:lt1>
+        <a:sysClr val="window" lastClr="FFFFFF"/>
+      </a:lt1>
+      <a:dk2>
+        <a:srgbClr val="0E2841"/>
+      </a:dk2>
+      <a:lt2>
+        <a:srgbClr val="E8E8E8"/>
+      </a:lt2>
+      <a:accent1>
+        <a:srgbClr val="156082"/>
+      </a:accent1>
+      <a:accent2>
+        <a:srgbClr val="E97132"/>
+      </a:accent2>
+      <a:accent3>
+        <a:srgbClr val="196B24"/>
+      </a:accent3>
+      <a:accent4>
+        <a:srgbClr val="0F9ED5"/>
+      </a:accent4>
+      <a:accent5>
+        <a:srgbClr val="A02B93"/>
+      </a:accent5>
+      <a:accent6>
+        <a:srgbClr val="4EA72E"/>
+      </a:accent6>
+      <a:hlink>
+        <a:srgbClr val="467886"/>
+      </a:hlink>
+      <a:folHlink>
+        <a:srgbClr val="96607D"/>
+      </a:folHlink>
+    </a:clrScheme>
+    <a:fontScheme name="Office">
+      <a:majorFont>
+        <a:latin typeface="Aptos Display" panose="02110004020202020204"/>
+        <a:ea typeface=""/>
+        <a:cs typeface=""/>
+        <a:font script="Jpan" typeface="游ゴシック Light"/>
+        <a:font script="Hang" typeface="맑은 고딕"/>
+        <a:font script="Hans" typeface="等线 Light"/>
+        <a:font script="Hant" typeface="新細明體"/>
+        <a:font script="Arab" typeface="Times New Roman"/>
+        <a:font script="Hebr" typeface="Times New Roman"/>
+        <a:font script="Thai" typeface="Angsana New"/>
+        <a:font script="Ethi" typeface="Nyala"/>
+        <a:font script="Beng" typeface="Vrinda"/>
+        <a:font script="Gujr" typeface="Shruti"/>
+        <a:font script="Khmr" typeface="MoolBoran"/>
+        <a:font script="Knda" typeface="Tunga"/>
+        <a:font script="Guru" typeface="Raavi"/>
+        <a:font script="Cans" typeface="Euphemia"/>
+        <a:font script="Cher" typeface="Plantagenet Cherokee"/>
+        <a:font script="Yiii" typeface="Microsoft Yi Baiti"/>
+        <a:font script="Tibt" typeface="Microsoft Himalaya"/>
+        <a:font script="Thaa" typeface="MV Boli"/>
+        <a:font script="Deva" typeface="Mangal"/>
+        <a:font script="Telu" typeface="Gautami"/>
+        <a:font script="Taml" typeface="Latha"/>
+        <a:font script="Syrc" typeface="Estrangelo Edessa"/>
+        <a:font script="Orya" typeface="Kalinga"/>
+        <a:font script="Mlym" typeface="Kartika"/>
+        <a:font script="Laoo" typeface="DokChampa"/>
+        <a:font script="Sinh" typeface="Iskoola Pota"/>
+        <a:font script="Mong" typeface="Mongolian Baiti"/>
+        <a:font script="Viet" typeface="Times New Roman"/>
+        <a:font script="Uigh" typeface="Microsoft Uighur"/>
+        <a:font script="Geor" typeface="Sylfaen"/>
+        <a:font script="Armn" typeface="Arial"/>
+        <a:font script="Bugi" typeface="Leelawadee UI"/>
+        <a:font script="Bopo" typeface="Microsoft JhengHei"/>
+        <a:font script="Java" typeface="Javanese Text"/>
+        <a:font script="Lisu" typeface="Segoe UI"/>
+        <a:font script="Mymr" typeface="Myanmar Text"/>
+        <a:font script="Nkoo" typeface="Ebrima"/>
+        <a:font script="Olck" typeface="Nirmala UI"/>
+        <a:font script="Osma" typeface="Ebrima"/>
+        <a:font script="Phag" typeface="Phagspa"/>
+        <a:font script="Syrn" typeface="Estrangelo Edessa"/>
+        <a:font script="Syrj" typeface="Estrangelo Edessa"/>
+        <a:font script="Syre" typeface="Estrangelo Edessa"/>
+        <a:font script="Sora" typeface="Nirmala UI"/>
+        <a:font script="Tale" typeface="Microsoft Tai Le"/>
+        <a:font script="Talu" typeface="Microsoft New Tai Lue"/>
+        <a:font script="Tfng" typeface="Ebrima"/>
+      </a:majorFont>
+      <a:minorFont>
+        <a:latin typeface="Aptos" panose="02110004020202020204"/>
+        <a:ea typeface=""/>
+        <a:cs typeface=""/>
+        <a:font script="Jpan" typeface="游ゴシック"/>
+        <a:font script="Hang" typeface="맑은 고딕"/>
+        <a:font script="Hans" typeface="等线"/>
+        <a:font script="Hant" typeface="新細明體"/>
+        <a:font script="Arab" typeface="Arial"/>
+        <a:font script="Hebr" typeface="Arial"/>
+        <a:font script="Thai" typeface="Cordia New"/>
+        <a:font script="Ethi" typeface="Nyala"/>
+        <a:font script="Beng" typeface="Vrinda"/>
+        <a:font script="Gujr" typeface="Shruti"/>
+        <a:font script="Khmr" typeface="DaunPenh"/>
+        <a:font script="Knda" typeface="Tunga"/>
+        <a:font script="Guru" typeface="Raavi"/>
+        <a:font script="Cans" typeface="Euphemia"/>
+        <a:font script="Cher" typeface="Plantagenet Cherokee"/>
+        <a:font script="Yiii" typeface="Microsoft Yi Baiti"/>
+        <a:font script="Tibt" typeface="Microsoft Himalaya"/>
+        <a:font script="Thaa" typeface="MV Boli"/>
+        <a:font script="Deva" typeface="Mangal"/>
+        <a:font script="Telu" typeface="Gautami"/>
+        <a:font script="Taml" typeface="Latha"/>
+        <a:font script="Syrc" typeface="Estrangelo Edessa"/>
+        <a:font script="Orya" typeface="Kalinga"/>
+        <a:font script="Mlym" typeface="Kartika"/>
+        <a:font script="Laoo" typeface="DokChampa"/>
+        <a:font script="Sinh" typeface="Iskoola Pota"/>
+        <a:font script="Mong" typeface="Mongolian Baiti"/>
+        <a:font script="Viet" typeface="Arial"/>
+        <a:font script="Uigh" typeface="Microsoft Uighur"/>
+        <a:font script="Geor" typeface="Sylfaen"/>
+        <a:font script="Armn" typeface="Arial"/>
+        <a:font script="Bugi" typeface="Leelawadee UI"/>
+        <a:font script="Bopo" typeface="Microsoft JhengHei"/>
+        <a:font script="Java" typeface="Javanese Text"/>
+        <a:font script="Lisu" typeface="Segoe UI"/>
+        <a:font script="Mymr" typeface="Myanmar Text"/>
+        <a:font script="Nkoo" typeface="Ebrima"/>
+        <a:font script="Olck" typeface="Nirmala UI"/>
+        <a:font script="Osma" typeface="Ebrima"/>
+        <a:font script="Phag" typeface="Phagspa"/>
+        <a:font script="Syrn" typeface="Estrangelo Edessa"/>
+        <a:font script="Syrj" typeface="Estrangelo Edessa"/>
+        <a:font script="Syre" typeface="Estrangelo Edessa"/>
+        <a:font script="Sora" typeface="Nirmala UI"/>
+        <a:font script="Tale" typeface="Microsoft Tai Le"/>
+        <a:font script="Talu" typeface="Microsoft New Tai Lue"/>
+        <a:font script="Tfng" typeface="Ebrima"/>
+      </a:minorFont>
+    </a:fontScheme>
+    <a:fmtScheme name="Office">
+      <a:fillStyleLst>
+        <a:solidFill>
+          <a:schemeClr val="phClr"/>
+        </a:solidFill>
+        <a:gradFill rotWithShape="1">
+          <a:gsLst>
+            <a:gs pos="0">
+              <a:schemeClr val="phClr">
+                <a:lumMod val="110000"/>
+                <a:satMod val="105000"/>
+                <a:tint val="67000"/>
+              </a:schemeClr>
+            </a:gs>
+            <a:gs pos="50000">
+              <a:schemeClr val="phClr">
+                <a:lumMod val="105000"/>
+                <a:satMod val="103000"/>
+                <a:tint val="73000"/>
+              </a:schemeClr>
+            </a:gs>
+            <a:gs pos="100000">
+              <a:schemeClr val="phClr">
+                <a:lumMod val="105000"/>
+                <a:satMod val="109000"/>
+                <a:tint val="81000"/>
+              </a:schemeClr>
+            </a:gs>
+          </a:gsLst>
+          <a:lin ang="5400000" scaled="0"/>
+        </a:gradFill>
+        <a:gradFill rotWithShape="1">
+          <a:gsLst>
+            <a:gs pos="0">
+              <a:schemeClr val="phClr">
+                <a:satMod val="103000"/>
+                <a:lumMod val="102000"/>
+                <a:tint val="94000"/>
+              </a:schemeClr>
+            </a:gs>
+            <a:gs pos="50000">
+              <a:schemeClr val="phClr">
+                <a:satMod val="110000"/>
+                <a:lumMod val="100000"/>
+                <a:shade val="100000"/>
+              </a:schemeClr>
+            </a:gs>
+            <a:gs pos="100000">
+              <a:schemeClr val="phClr">
+                <a:lumMod val="99000"/>
+                <a:satMod val="120000"/>
+                <a:shade val="78000"/>
+              </a:schemeClr>
+            </a:gs>
+          </a:gsLst>
+          <a:lin ang="5400000" scaled="0"/>
+        </a:gradFill>
+      </a:fillStyleLst>
+      <a:lnStyleLst>
+        <a:ln w="12700" cap="flat" cmpd="sng" algn="ctr">
+          <a:solidFill>
+            <a:schemeClr val="phClr"/>
+          </a:solidFill>
+          <a:prstDash val="solid"/>
+          <a:miter lim="800000"/>
+        </a:ln>
+        <a:ln w="19050" cap="flat" cmpd="sng" algn="ctr">
+          <a:solidFill>
+            <a:schemeClr val="phClr"/>
+          </a:solidFill>
+          <a:prstDash val="solid"/>
+          <a:miter lim="800000"/>
+        </a:ln>
+        <a:ln w="25400" cap="flat" cmpd="sng" algn="ctr">
+          <a:solidFill>
+            <a:schemeClr val="phClr"/>
+          </a:solidFill>
+          <a:prstDash val="solid"/>
+          <a:miter lim="800000"/>
+        </a:ln>
+      </a:lnStyleLst>
+      <a:effectStyleLst>
+        <a:effectStyle>
+          <a:effectLst/>
+        </a:effectStyle>
+        <a:effectStyle>
+          <a:effectLst/>
+        </a:effectStyle>
+        <a:effectStyle>
+          <a:effectLst>
+            <a:outerShdw blurRad="57150" dist="19050" dir="5400000" algn="ctr" rotWithShape="0">
+              <a:srgbClr val="000000">
+                <a:alpha val="63000"/>
+              </a:srgbClr>
+            </a:outerShdw>
+          </a:effectLst>
+        </a:effectStyle>
+      </a:effectStyleLst>
+      <a:bgFillStyleLst>
+        <a:solidFill>
+          <a:schemeClr val="phClr"/>
+        </a:solidFill>
+        <a:solidFill>
+          <a:schemeClr val="phClr">
+            <a:tint val="95000"/>
+            <a:satMod val="170000"/>
+          </a:schemeClr>
+        </a:solidFill>
+        <a:gradFill rotWithShape="1">
+          <a:gsLst>
+            <a:gs pos="0">
+              <a:schemeClr val="phClr">
+                <a:tint val="93000"/>
+                <a:satMod val="150000"/>
+                <a:shade val="98000"/>
+                <a:lumMod val="102000"/>
+              </a:schemeClr>
+            </a:gs>
+            <a:gs pos="50000">
+              <a:schemeClr val="phClr">
+                <a:tint val="98000"/>
+                <a:satMod val="130000"/>
+                <a:shade val="90000"/>
+                <a:lumMod val="103000"/>
+              </a:schemeClr>
+            </a:gs>
+            <a:gs pos="100000">
+              <a:schemeClr val="phClr">
+                <a:shade val="63000"/>
+                <a:satMod val="120000"/>
+              </a:schemeClr>
+            </a:gs>
+          </a:gsLst>
+          <a:lin ang="5400000" scaled="0"/>
+        </a:gradFill>
+      </a:bgFillStyleLst>
+    </a:fmtScheme>
+  </a:themeElements>
+  <a:objectDefaults>
+    <a:lnDef>
+      <a:spPr/>
+      <a:bodyPr/>
+      <a:lstStyle/>
+      <a:style>
+        <a:lnRef idx="2">
+          <a:schemeClr val="accent1"/>
+        </a:lnRef>
+        <a:fillRef idx="0">
+          <a:schemeClr val="accent1"/>
+        </a:fillRef>
+        <a:effectRef idx="1">
+          <a:schemeClr val="accent1"/>
+        </a:effectRef>
+        <a:fontRef idx="minor">
+          <a:schemeClr val="tx1"/>
+        </a:fontRef>
+      </a:style>
+    </a:lnDef>
+  </a:objectDefaults>
+  <a:extraClrSchemeLst/>
+  <a:extLst>
+    <a:ext uri="{05A4C25C-085E-4340-85A3-A5531E510DB2}">
+      <thm15:themeFamily xmlns:thm15="http://schemas.microsoft.com/office/thememl/2012/main" name="Office Theme" id="{2E142A2C-CD16-42D6-873A-C26D2A0506FA}" vid="{1BDDFF52-6CD6-40A5-AB3C-68EB2F1E4D0A}"/>
+    </a:ext>
+  </a:extLst>
+</a:theme>
 </file>
</xml_diff>

<commit_message>
Add CloudWatch CPU alarm and SNS email notification via Terraform (#1)
* Add CloudWatch CPU alarm and SNS email notification via Terraform

- Added infrastructure/cloudwatch.tf:
  - aws_sns_topic: notification channel for CPU alerts
  - aws_sns_topic_subscription: email subscription (alert_email var)
  - aws_cloudwatch_metric_alarm: fires when EC2 CPU > 80% for 5 min
  - Output: prints SNS topic ARN after apply
- Added alert_email variable to infrastructure/variables.tf
- Updated AWS architecture diagram

* The last session done

---------

Co-authored-by: George Too <george.too@greenstemglobal.com>
</commit_message>
<xml_diff>
--- a/Assets/AWS_Architecture.pptx
+++ b/Assets/AWS_Architecture.pptx
@@ -4,13 +4,13 @@
   <p:sldMasterIdLst>
     <p:sldMasterId id="2147483648" r:id="rId1"/>
   </p:sldMasterIdLst>
+  <p:notesMasterIdLst>
+    <p:notesMasterId r:id="rId3"/>
+  </p:notesMasterIdLst>
   <p:sldIdLst>
     <p:sldId id="256" r:id="rId2"/>
   </p:sldIdLst>
-  <p:notesMasterIdLst>
-    <p:notesMasterId r:id="rId3"/>
-  </p:notesMasterIdLst>
-  <p:sldSz cx="9144000" cy="5143500"/>
+  <p:sldSz cx="9144000" cy="5143500" type="screen16x9"/>
   <p:notesSz cx="5143500" cy="9144000"/>
   <p:defaultTextStyle>
     <a:lvl1pPr marL="0" algn="l" defTabSz="914400" rtl="0" eaLnBrk="1" latinLnBrk="0" hangingPunct="1">
@@ -104,6 +104,11 @@
       </a:defRPr>
     </a:lvl9pPr>
   </p:defaultTextStyle>
+  <p:extLst>
+    <p:ext uri="{EFAFB233-063F-42B5-8137-9DF3F51BA10A}">
+      <p15:sldGuideLst xmlns:p15="http://schemas.microsoft.com/office/powerpoint/2012/main"/>
+    </p:ext>
+  </p:extLst>
 </p:presentation>
 </file>
 
@@ -129,234 +134,10 @@
           <a:chExt cx="0" cy="0"/>
         </a:xfrm>
       </p:grpSpPr>
-      <p:sp>
-        <p:nvSpPr>
-          <p:cNvPr id="2" name="Header Placeholder 1"/>
-          <p:cNvSpPr>
-            <a:spLocks noGrp="1"/>
-          </p:cNvSpPr>
-          <p:nvPr>
-            <p:ph type="hdr" sz="quarter"/>
-          </p:nvPr>
-        </p:nvSpPr>
-        <p:spPr>
-          <a:xfrm>
-            <a:off x="0" y="0"/>
-            <a:ext cx="2971800" cy="458788"/>
-          </a:xfrm>
-          <a:prstGeom prst="rect">
-            <a:avLst/>
-          </a:prstGeom>
-        </p:spPr>
-        <p:txBody>
-          <a:bodyPr vert="horz" lIns="91440" tIns="45720" rIns="91440" bIns="45720" rtlCol="0"/>
-          <a:lstStyle>
-            <a:lvl1pPr algn="l">
-              <a:defRPr sz="1200"/>
-            </a:lvl1pPr>
-          </a:lstStyle>
-          <a:p>
-            <a:endParaRPr lang="en-US"/>
-          </a:p>
-        </p:txBody>
-      </p:sp>
-      <p:sp>
-        <p:nvSpPr>
-          <p:cNvPr id="3" name="Date Placeholder 2"/>
-          <p:cNvSpPr>
-            <a:spLocks noGrp="1"/>
-          </p:cNvSpPr>
-          <p:nvPr>
-            <p:ph type="dt" idx="1"/>
-          </p:nvPr>
-        </p:nvSpPr>
-        <p:spPr>
-          <a:xfrm>
-            <a:off x="3884613" y="0"/>
-            <a:ext cx="2971800" cy="458788"/>
-          </a:xfrm>
-          <a:prstGeom prst="rect">
-            <a:avLst/>
-          </a:prstGeom>
-        </p:spPr>
-        <p:txBody>
-          <a:bodyPr vert="horz" lIns="91440" tIns="45720" rIns="91440" bIns="45720" rtlCol="0"/>
-          <a:lstStyle>
-            <a:lvl1pPr algn="r">
-              <a:defRPr sz="1200"/>
-            </a:lvl1pPr>
-          </a:lstStyle>
-          <a:p>
-            <a:fld id="{5282F153-3F37-0F45-9E97-73ACFA13230C}" type="datetimeFigureOut">
-              <a:rPr lang="en-US"/>
-              <a:t>7/23/19</a:t>
-            </a:fld>
-            <a:endParaRPr lang="en-US"/>
-          </a:p>
-        </p:txBody>
-      </p:sp>
-      <p:sp>
-        <p:nvSpPr>
-          <p:cNvPr id="4" name="Slide Image Placeholder 3"/>
-          <p:cNvSpPr>
-            <a:spLocks noGrp="1" noRot="1" noChangeAspect="1"/>
-          </p:cNvSpPr>
-          <p:nvPr>
-            <p:ph type="sldImg" idx="2"/>
-          </p:nvPr>
-        </p:nvSpPr>
-        <p:spPr>
-          <a:xfrm>
-            <a:off x="685800" y="1143000"/>
-            <a:ext cx="5486400" cy="3086100"/>
-          </a:xfrm>
-          <a:prstGeom prst="rect">
-            <a:avLst/>
-          </a:prstGeom>
-          <a:noFill/>
-          <a:ln w="12700">
-            <a:solidFill>
-              <a:prstClr val="black"/>
-            </a:solidFill>
-          </a:ln>
-        </p:spPr>
-        <p:txBody>
-          <a:bodyPr vert="horz" lIns="91440" tIns="45720" rIns="91440" bIns="45720" rtlCol="0" anchor="ctr"/>
-          <a:lstStyle/>
-          <a:p>
-            <a:endParaRPr lang="en-US"/>
-          </a:p>
-        </p:txBody>
-      </p:sp>
-      <p:sp>
-        <p:nvSpPr>
-          <p:cNvPr id="5" name="Notes Placeholder 4"/>
-          <p:cNvSpPr>
-            <a:spLocks noGrp="1"/>
-          </p:cNvSpPr>
-          <p:nvPr>
-            <p:ph type="body" sz="quarter" idx="3"/>
-          </p:nvPr>
-        </p:nvSpPr>
-        <p:spPr>
-          <a:xfrm>
-            <a:off x="685800" y="4400550"/>
-            <a:ext cx="5486400" cy="3600450"/>
-          </a:xfrm>
-          <a:prstGeom prst="rect">
-            <a:avLst/>
-          </a:prstGeom>
-        </p:spPr>
-        <p:txBody>
-          <a:bodyPr vert="horz" lIns="91440" tIns="45720" rIns="91440" bIns="45720" rtlCol="0"/>
-          <a:lstStyle/>
-          <a:p>
-            <a:pPr lvl="0"/>
-            <a:r>
-              <a:rPr lang="en-US"/>
-              <a:t>Click to edit Master text styles</a:t>
-            </a:r>
-          </a:p>
-          <a:p>
-            <a:pPr lvl="1"/>
-            <a:r>
-              <a:rPr lang="en-US"/>
-              <a:t>Second level</a:t>
-            </a:r>
-          </a:p>
-          <a:p>
-            <a:pPr lvl="2"/>
-            <a:r>
-              <a:rPr lang="en-US"/>
-              <a:t>Third level</a:t>
-            </a:r>
-          </a:p>
-          <a:p>
-            <a:pPr lvl="3"/>
-            <a:r>
-              <a:rPr lang="en-US"/>
-              <a:t>Fourth level</a:t>
-            </a:r>
-          </a:p>
-          <a:p>
-            <a:pPr lvl="4"/>
-            <a:r>
-              <a:rPr lang="en-US"/>
-              <a:t>Fifth level</a:t>
-            </a:r>
-          </a:p>
-        </p:txBody>
-      </p:sp>
-      <p:sp>
-        <p:nvSpPr>
-          <p:cNvPr id="6" name="Footer Placeholder 5"/>
-          <p:cNvSpPr>
-            <a:spLocks noGrp="1"/>
-          </p:cNvSpPr>
-          <p:nvPr>
-            <p:ph type="ftr" sz="quarter" idx="4"/>
-          </p:nvPr>
-        </p:nvSpPr>
-        <p:spPr>
-          <a:xfrm>
-            <a:off x="0" y="8685213"/>
-            <a:ext cx="2971800" cy="458787"/>
-          </a:xfrm>
-          <a:prstGeom prst="rect">
-            <a:avLst/>
-          </a:prstGeom>
-        </p:spPr>
-        <p:txBody>
-          <a:bodyPr vert="horz" lIns="91440" tIns="45720" rIns="91440" bIns="45720" rtlCol="0" anchor="b"/>
-          <a:lstStyle>
-            <a:lvl1pPr algn="l">
-              <a:defRPr sz="1200"/>
-            </a:lvl1pPr>
-          </a:lstStyle>
-          <a:p>
-            <a:endParaRPr lang="en-US"/>
-          </a:p>
-        </p:txBody>
-      </p:sp>
-      <p:sp>
-        <p:nvSpPr>
-          <p:cNvPr id="7" name="Slide Number Placeholder 6"/>
-          <p:cNvSpPr>
-            <a:spLocks noGrp="1"/>
-          </p:cNvSpPr>
-          <p:nvPr>
-            <p:ph type="sldNum" sz="quarter" idx="5"/>
-          </p:nvPr>
-        </p:nvSpPr>
-        <p:spPr>
-          <a:xfrm>
-            <a:off x="3884613" y="8685213"/>
-            <a:ext cx="2971800" cy="458787"/>
-          </a:xfrm>
-          <a:prstGeom prst="rect">
-            <a:avLst/>
-          </a:prstGeom>
-        </p:spPr>
-        <p:txBody>
-          <a:bodyPr vert="horz" lIns="91440" tIns="45720" rIns="91440" bIns="45720" rtlCol="0" anchor="b"/>
-          <a:lstStyle>
-            <a:lvl1pPr algn="r">
-              <a:defRPr sz="1200"/>
-            </a:lvl1pPr>
-          </a:lstStyle>
-          <a:p>
-            <a:fld id="{CE5E9CC1-C706-0F49-92D6-E571CC5EEA8F}" type="slidenum">
-              <a:rPr lang="en-US"/>
-              <a:t>‹#›</a:t>
-            </a:fld>
-            <a:endParaRPr lang="en-US"/>
-          </a:p>
-        </p:txBody>
-      </p:sp>
     </p:spTree>
     <p:extLst>
       <p:ext uri="{BB962C8B-B14F-4D97-AF65-F5344CB8AC3E}">
-        <p14:creationId xmlns:p14="http://schemas.microsoft.com/office/powerpoint/2010/main" val="1024086991"/>
+        <p14:creationId xmlns:p14="http://schemas.microsoft.com/office/powerpoint/2010/main" val="910708791"/>
       </p:ext>
     </p:extLst>
   </p:cSld>
@@ -500,10 +281,6 @@
           <a:bodyPr/>
           <a:lstStyle/>
           <a:p>
-            <a:r>
-              <a:rPr lang="en-US" dirty="0"/>
-              <a:t/>
-            </a:r>
             <a:endParaRPr lang="en-US" dirty="0"/>
           </a:p>
         </p:txBody>
@@ -577,6 +354,11 @@
 <file path=ppt/slideMasters/slideMaster1.xml><?xml version="1.0" encoding="utf-8"?>
 <p:sldMaster xmlns:a="http://schemas.openxmlformats.org/drawingml/2006/main" xmlns:r="http://schemas.openxmlformats.org/officeDocument/2006/relationships" xmlns:p="http://schemas.openxmlformats.org/presentationml/2006/main">
   <p:cSld>
+    <p:bg>
+      <p:bgRef idx="1001">
+        <a:schemeClr val="bg1"/>
+      </p:bgRef>
+    </p:bg>
     <p:spTree>
       <p:nvGrpSpPr>
         <p:cNvPr id="1" name=""/>
@@ -859,6 +641,7 @@
         <a:solidFill>
           <a:srgbClr val="0D1B2A"/>
         </a:solidFill>
+        <a:effectLst/>
       </p:bgPr>
     </p:bg>
     <p:spTree>
@@ -883,7 +666,7 @@
         </p:nvSpPr>
         <p:spPr>
           <a:xfrm>
-            <a:off x="365760" y="182880"/>
+            <a:off x="365760" y="164592"/>
             <a:ext cx="8412480" cy="502920"/>
           </a:xfrm>
           <a:prstGeom prst="rect">
@@ -896,7 +679,7 @@
           <a:bodyPr wrap="square" lIns="0" tIns="0" rIns="0" bIns="0" rtlCol="0" anchor="ctr"/>
           <a:lstStyle/>
           <a:p>
-            <a:pPr algn="l" indent="0" marL="0">
+            <a:pPr marL="0" indent="0" algn="l">
               <a:buNone/>
             </a:pPr>
             <a:r>
@@ -922,8 +705,8 @@
         </p:nvSpPr>
         <p:spPr>
           <a:xfrm>
-            <a:off x="365760" y="658368"/>
-            <a:ext cx="8412480" cy="292608"/>
+            <a:off x="365760" y="640080"/>
+            <a:ext cx="8412480" cy="274320"/>
           </a:xfrm>
           <a:prstGeom prst="rect">
             <a:avLst/>
@@ -935,19 +718,19 @@
           <a:bodyPr wrap="square" lIns="0" tIns="0" rIns="0" bIns="0" rtlCol="0" anchor="ctr"/>
           <a:lstStyle/>
           <a:p>
-            <a:pPr algn="l" indent="0" marL="0">
+            <a:pPr marL="0" indent="0" algn="l">
               <a:buNone/>
             </a:pPr>
             <a:r>
               <a:rPr lang="en-US" sz="1300" dirty="0">
                 <a:solidFill>
-                  <a:srgbClr val="6B8BAE"/>
+                  <a:srgbClr val="5A7A9A"/>
                 </a:solidFill>
                 <a:latin typeface="Calibri" pitchFamily="34" charset="0"/>
                 <a:ea typeface="Calibri" pitchFamily="34" charset="-122"/>
                 <a:cs typeface="Calibri" pitchFamily="34" charset="-120"/>
               </a:rPr>
-              <a:t>Grocery Store Project · Masterschools</a:t>
+              <a:t>Grocery Store</a:t>
             </a:r>
             <a:endParaRPr lang="en-US" sz="1300" dirty="0"/>
           </a:p>
@@ -961,14 +744,195 @@
         </p:nvSpPr>
         <p:spPr>
           <a:xfrm>
-            <a:off x="2011680" y="1051560"/>
-            <a:ext cx="6766560" cy="3749040"/>
-          </a:xfrm>
-          <a:prstGeom prst="rect">
-            <a:avLst/>
-          </a:prstGeom>
-          <a:solidFill>
-            <a:srgbClr val="1A2F48"/>
+            <a:off x="2045970" y="983557"/>
+            <a:ext cx="6803136" cy="3725604"/>
+          </a:xfrm>
+          <a:custGeom>
+            <a:avLst/>
+            <a:gdLst>
+              <a:gd name="csX0" fmla="*/ 0 w 6803136"/>
+              <a:gd name="csY0" fmla="*/ 0 h 3685032"/>
+              <a:gd name="csX1" fmla="*/ 6803136 w 6803136"/>
+              <a:gd name="csY1" fmla="*/ 0 h 3685032"/>
+              <a:gd name="csX2" fmla="*/ 6803136 w 6803136"/>
+              <a:gd name="csY2" fmla="*/ 3685032 h 3685032"/>
+              <a:gd name="csX3" fmla="*/ 0 w 6803136"/>
+              <a:gd name="csY3" fmla="*/ 3685032 h 3685032"/>
+              <a:gd name="csX4" fmla="*/ 0 w 6803136"/>
+              <a:gd name="csY4" fmla="*/ 0 h 3685032"/>
+              <a:gd name="csX0" fmla="*/ 0 w 6803136"/>
+              <a:gd name="csY0" fmla="*/ 0 h 3685032"/>
+              <a:gd name="csX1" fmla="*/ 6795452 w 6803136"/>
+              <a:gd name="csY1" fmla="*/ 0 h 3685032"/>
+              <a:gd name="csX2" fmla="*/ 6803136 w 6803136"/>
+              <a:gd name="csY2" fmla="*/ 3685032 h 3685032"/>
+              <a:gd name="csX3" fmla="*/ 0 w 6803136"/>
+              <a:gd name="csY3" fmla="*/ 3685032 h 3685032"/>
+              <a:gd name="csX4" fmla="*/ 0 w 6803136"/>
+              <a:gd name="csY4" fmla="*/ 0 h 3685032"/>
+              <a:gd name="csX0" fmla="*/ 0 w 6803136"/>
+              <a:gd name="csY0" fmla="*/ 0 h 3685032"/>
+              <a:gd name="csX1" fmla="*/ 6795452 w 6803136"/>
+              <a:gd name="csY1" fmla="*/ 0 h 3685032"/>
+              <a:gd name="csX2" fmla="*/ 6803136 w 6803136"/>
+              <a:gd name="csY2" fmla="*/ 3685032 h 3685032"/>
+              <a:gd name="csX3" fmla="*/ 0 w 6803136"/>
+              <a:gd name="csY3" fmla="*/ 3685032 h 3685032"/>
+              <a:gd name="csX4" fmla="*/ 0 w 6803136"/>
+              <a:gd name="csY4" fmla="*/ 0 h 3685032"/>
+              <a:gd name="csX0" fmla="*/ 0 w 6803136"/>
+              <a:gd name="csY0" fmla="*/ 0 h 3685032"/>
+              <a:gd name="csX1" fmla="*/ 6795452 w 6803136"/>
+              <a:gd name="csY1" fmla="*/ 0 h 3685032"/>
+              <a:gd name="csX2" fmla="*/ 6803136 w 6803136"/>
+              <a:gd name="csY2" fmla="*/ 3685032 h 3685032"/>
+              <a:gd name="csX3" fmla="*/ 0 w 6803136"/>
+              <a:gd name="csY3" fmla="*/ 3685032 h 3685032"/>
+              <a:gd name="csX4" fmla="*/ 0 w 6803136"/>
+              <a:gd name="csY4" fmla="*/ 0 h 3685032"/>
+              <a:gd name="csX0" fmla="*/ 0 w 6803136"/>
+              <a:gd name="csY0" fmla="*/ 376518 h 4061550"/>
+              <a:gd name="csX1" fmla="*/ 6780084 w 6803136"/>
+              <a:gd name="csY1" fmla="*/ 0 h 4061550"/>
+              <a:gd name="csX2" fmla="*/ 6803136 w 6803136"/>
+              <a:gd name="csY2" fmla="*/ 4061550 h 4061550"/>
+              <a:gd name="csX3" fmla="*/ 0 w 6803136"/>
+              <a:gd name="csY3" fmla="*/ 4061550 h 4061550"/>
+              <a:gd name="csX4" fmla="*/ 0 w 6803136"/>
+              <a:gd name="csY4" fmla="*/ 376518 h 4061550"/>
+              <a:gd name="csX0" fmla="*/ 0 w 6803136"/>
+              <a:gd name="csY0" fmla="*/ 46105 h 3731137"/>
+              <a:gd name="csX1" fmla="*/ 6795452 w 6803136"/>
+              <a:gd name="csY1" fmla="*/ 0 h 3731137"/>
+              <a:gd name="csX2" fmla="*/ 6803136 w 6803136"/>
+              <a:gd name="csY2" fmla="*/ 3731137 h 3731137"/>
+              <a:gd name="csX3" fmla="*/ 0 w 6803136"/>
+              <a:gd name="csY3" fmla="*/ 3731137 h 3731137"/>
+              <a:gd name="csX4" fmla="*/ 0 w 6803136"/>
+              <a:gd name="csY4" fmla="*/ 46105 h 3731137"/>
+              <a:gd name="csX0" fmla="*/ 0 w 6803136"/>
+              <a:gd name="csY0" fmla="*/ 46105 h 3731137"/>
+              <a:gd name="csX1" fmla="*/ 2683649 w 6803136"/>
+              <a:gd name="csY1" fmla="*/ 13217 h 3731137"/>
+              <a:gd name="csX2" fmla="*/ 6795452 w 6803136"/>
+              <a:gd name="csY2" fmla="*/ 0 h 3731137"/>
+              <a:gd name="csX3" fmla="*/ 6803136 w 6803136"/>
+              <a:gd name="csY3" fmla="*/ 3731137 h 3731137"/>
+              <a:gd name="csX4" fmla="*/ 0 w 6803136"/>
+              <a:gd name="csY4" fmla="*/ 3731137 h 3731137"/>
+              <a:gd name="csX5" fmla="*/ 0 w 6803136"/>
+              <a:gd name="csY5" fmla="*/ 46105 h 3731137"/>
+              <a:gd name="csX0" fmla="*/ 0 w 6803136"/>
+              <a:gd name="csY0" fmla="*/ 46105 h 3731137"/>
+              <a:gd name="csX1" fmla="*/ 2675965 w 6803136"/>
+              <a:gd name="csY1" fmla="*/ 5533 h 3731137"/>
+              <a:gd name="csX2" fmla="*/ 6795452 w 6803136"/>
+              <a:gd name="csY2" fmla="*/ 0 h 3731137"/>
+              <a:gd name="csX3" fmla="*/ 6803136 w 6803136"/>
+              <a:gd name="csY3" fmla="*/ 3731137 h 3731137"/>
+              <a:gd name="csX4" fmla="*/ 0 w 6803136"/>
+              <a:gd name="csY4" fmla="*/ 3731137 h 3731137"/>
+              <a:gd name="csX5" fmla="*/ 0 w 6803136"/>
+              <a:gd name="csY5" fmla="*/ 46105 h 3731137"/>
+              <a:gd name="csX0" fmla="*/ 0 w 6803136"/>
+              <a:gd name="csY0" fmla="*/ 48256 h 3733288"/>
+              <a:gd name="csX1" fmla="*/ 2675965 w 6803136"/>
+              <a:gd name="csY1" fmla="*/ 7684 h 3733288"/>
+              <a:gd name="csX2" fmla="*/ 2660597 w 6803136"/>
+              <a:gd name="csY2" fmla="*/ 0 h 3733288"/>
+              <a:gd name="csX3" fmla="*/ 6795452 w 6803136"/>
+              <a:gd name="csY3" fmla="*/ 2151 h 3733288"/>
+              <a:gd name="csX4" fmla="*/ 6803136 w 6803136"/>
+              <a:gd name="csY4" fmla="*/ 3733288 h 3733288"/>
+              <a:gd name="csX5" fmla="*/ 0 w 6803136"/>
+              <a:gd name="csY5" fmla="*/ 3733288 h 3733288"/>
+              <a:gd name="csX6" fmla="*/ 0 w 6803136"/>
+              <a:gd name="csY6" fmla="*/ 48256 h 3733288"/>
+              <a:gd name="csX0" fmla="*/ 0 w 6803136"/>
+              <a:gd name="csY0" fmla="*/ 46105 h 3731137"/>
+              <a:gd name="csX1" fmla="*/ 2675965 w 6803136"/>
+              <a:gd name="csY1" fmla="*/ 5533 h 3731137"/>
+              <a:gd name="csX2" fmla="*/ 2675965 w 6803136"/>
+              <a:gd name="csY2" fmla="*/ 1012142 h 3731137"/>
+              <a:gd name="csX3" fmla="*/ 6795452 w 6803136"/>
+              <a:gd name="csY3" fmla="*/ 0 h 3731137"/>
+              <a:gd name="csX4" fmla="*/ 6803136 w 6803136"/>
+              <a:gd name="csY4" fmla="*/ 3731137 h 3731137"/>
+              <a:gd name="csX5" fmla="*/ 0 w 6803136"/>
+              <a:gd name="csY5" fmla="*/ 3731137 h 3731137"/>
+              <a:gd name="csX6" fmla="*/ 0 w 6803136"/>
+              <a:gd name="csY6" fmla="*/ 46105 h 3731137"/>
+              <a:gd name="csX0" fmla="*/ 0 w 6803136"/>
+              <a:gd name="csY0" fmla="*/ 40572 h 3725604"/>
+              <a:gd name="csX1" fmla="*/ 2675965 w 6803136"/>
+              <a:gd name="csY1" fmla="*/ 0 h 3725604"/>
+              <a:gd name="csX2" fmla="*/ 2675965 w 6803136"/>
+              <a:gd name="csY2" fmla="*/ 1006609 h 3725604"/>
+              <a:gd name="csX3" fmla="*/ 6787768 w 6803136"/>
+              <a:gd name="csY3" fmla="*/ 993392 h 3725604"/>
+              <a:gd name="csX4" fmla="*/ 6803136 w 6803136"/>
+              <a:gd name="csY4" fmla="*/ 3725604 h 3725604"/>
+              <a:gd name="csX5" fmla="*/ 0 w 6803136"/>
+              <a:gd name="csY5" fmla="*/ 3725604 h 3725604"/>
+              <a:gd name="csX6" fmla="*/ 0 w 6803136"/>
+              <a:gd name="csY6" fmla="*/ 40572 h 3725604"/>
+            </a:gdLst>
+            <a:ahLst/>
+            <a:cxnLst>
+              <a:cxn ang="0">
+                <a:pos x="csX0" y="csY0"/>
+              </a:cxn>
+              <a:cxn ang="0">
+                <a:pos x="csX1" y="csY1"/>
+              </a:cxn>
+              <a:cxn ang="0">
+                <a:pos x="csX2" y="csY2"/>
+              </a:cxn>
+              <a:cxn ang="0">
+                <a:pos x="csX3" y="csY3"/>
+              </a:cxn>
+              <a:cxn ang="0">
+                <a:pos x="csX4" y="csY4"/>
+              </a:cxn>
+              <a:cxn ang="0">
+                <a:pos x="csX5" y="csY5"/>
+              </a:cxn>
+              <a:cxn ang="0">
+                <a:pos x="csX6" y="csY6"/>
+              </a:cxn>
+            </a:cxnLst>
+            <a:rect l="l" t="t" r="r" b="b"/>
+            <a:pathLst>
+              <a:path w="6803136" h="3725604">
+                <a:moveTo>
+                  <a:pt x="0" y="40572"/>
+                </a:moveTo>
+                <a:lnTo>
+                  <a:pt x="2675965" y="0"/>
+                </a:lnTo>
+                <a:lnTo>
+                  <a:pt x="2675965" y="1006609"/>
+                </a:lnTo>
+                <a:lnTo>
+                  <a:pt x="6787768" y="993392"/>
+                </a:lnTo>
+                <a:cubicBezTo>
+                  <a:pt x="6790329" y="2221736"/>
+                  <a:pt x="6800575" y="2497260"/>
+                  <a:pt x="6803136" y="3725604"/>
+                </a:cubicBezTo>
+                <a:lnTo>
+                  <a:pt x="0" y="3725604"/>
+                </a:lnTo>
+                <a:lnTo>
+                  <a:pt x="0" y="40572"/>
+                </a:lnTo>
+                <a:close/>
+              </a:path>
+            </a:pathLst>
+          </a:custGeom>
+          <a:solidFill>
+            <a:srgbClr val="111E2D"/>
           </a:solidFill>
           <a:ln w="15240">
             <a:solidFill>
@@ -977,6 +941,13 @@
             <a:prstDash val="dash"/>
           </a:ln>
         </p:spPr>
+        <p:txBody>
+          <a:bodyPr/>
+          <a:lstStyle/>
+          <a:p>
+            <a:endParaRPr lang="en-US"/>
+          </a:p>
+        </p:txBody>
       </p:sp>
       <p:sp>
         <p:nvSpPr>
@@ -986,8 +957,8 @@
         </p:nvSpPr>
         <p:spPr>
           <a:xfrm>
-            <a:off x="2057400" y="1097280"/>
-            <a:ext cx="1645920" cy="256032"/>
+            <a:off x="2148840" y="1051560"/>
+            <a:ext cx="1463040" cy="228600"/>
           </a:xfrm>
           <a:prstGeom prst="rect">
             <a:avLst/>
@@ -999,7 +970,7 @@
           <a:bodyPr wrap="square" lIns="0" tIns="0" rIns="0" bIns="0" rtlCol="0" anchor="ctr"/>
           <a:lstStyle/>
           <a:p>
-            <a:pPr indent="0" marL="0">
+            <a:pPr marL="0" indent="0" algn="l">
               <a:buNone/>
             </a:pPr>
             <a:r>
@@ -1025,14 +996,14 @@
         </p:nvSpPr>
         <p:spPr>
           <a:xfrm>
-            <a:off x="182880" y="1783080"/>
-            <a:ext cx="1691640" cy="658368"/>
-          </a:xfrm>
-          <a:prstGeom prst="rect">
-            <a:avLst/>
-          </a:prstGeom>
-          <a:solidFill>
-            <a:srgbClr val="163027"/>
+            <a:off x="91440" y="2715768"/>
+            <a:ext cx="1737360" cy="658368"/>
+          </a:xfrm>
+          <a:prstGeom prst="rect">
+            <a:avLst/>
+          </a:prstGeom>
+          <a:solidFill>
+            <a:srgbClr val="122A20"/>
           </a:solidFill>
           <a:ln w="12700">
             <a:solidFill>
@@ -1040,14 +1011,14 @@
             </a:solidFill>
             <a:prstDash val="solid"/>
           </a:ln>
-          <a:effectLst>
-            <a:outerShdw sx="100000" sy="100000" kx="0" ky="0" algn="bl" rotWithShape="0" blurRad="101600" dist="38100" dir="8100000">
-              <a:srgbClr val="000000">
-                <a:alpha val="30000"/>
-              </a:srgbClr>
-            </a:outerShdw>
-          </a:effectLst>
-        </p:spPr>
+        </p:spPr>
+        <p:txBody>
+          <a:bodyPr/>
+          <a:lstStyle/>
+          <a:p>
+            <a:endParaRPr lang="en-US" dirty="0"/>
+          </a:p>
+        </p:txBody>
       </p:sp>
       <p:sp>
         <p:nvSpPr>
@@ -1057,7 +1028,7 @@
         </p:nvSpPr>
         <p:spPr>
           <a:xfrm>
-            <a:off x="182880" y="1783080"/>
+            <a:off x="112014" y="2711196"/>
             <a:ext cx="64008" cy="658368"/>
           </a:xfrm>
           <a:prstGeom prst="rect">
@@ -1073,6 +1044,13 @@
             <a:prstDash val="solid"/>
           </a:ln>
         </p:spPr>
+        <p:txBody>
+          <a:bodyPr/>
+          <a:lstStyle/>
+          <a:p>
+            <a:endParaRPr lang="en-US"/>
+          </a:p>
+        </p:txBody>
       </p:sp>
       <p:sp>
         <p:nvSpPr>
@@ -1082,8 +1060,8 @@
         </p:nvSpPr>
         <p:spPr>
           <a:xfrm>
-            <a:off x="320040" y="1874520"/>
-            <a:ext cx="1508760" cy="256032"/>
+            <a:off x="324612" y="2807208"/>
+            <a:ext cx="1572768" cy="256032"/>
           </a:xfrm>
           <a:prstGeom prst="rect">
             <a:avLst/>
@@ -1095,7 +1073,7 @@
           <a:bodyPr wrap="square" lIns="0" tIns="0" rIns="0" bIns="0" rtlCol="0" anchor="ctr"/>
           <a:lstStyle/>
           <a:p>
-            <a:pPr indent="0" marL="0">
+            <a:pPr marL="0" indent="0" algn="l">
               <a:buNone/>
             </a:pPr>
             <a:r>
@@ -1107,7 +1085,7 @@
                 <a:ea typeface="Calibri" pitchFamily="34" charset="-122"/>
                 <a:cs typeface="Calibri" pitchFamily="34" charset="-120"/>
               </a:rPr>
-              <a:t>React</a:t>
+              <a:t>User</a:t>
             </a:r>
             <a:endParaRPr lang="en-US" sz="1200" dirty="0"/>
           </a:p>
@@ -1121,8 +1099,8 @@
         </p:nvSpPr>
         <p:spPr>
           <a:xfrm>
-            <a:off x="320040" y="2103120"/>
-            <a:ext cx="1508760" cy="201168"/>
+            <a:off x="324612" y="3063240"/>
+            <a:ext cx="1572768" cy="201168"/>
           </a:xfrm>
           <a:prstGeom prst="rect">
             <a:avLst/>
@@ -1134,20 +1112,9 @@
           <a:bodyPr wrap="square" lIns="0" tIns="0" rIns="0" bIns="0" rtlCol="0" anchor="ctr"/>
           <a:lstStyle/>
           <a:p>
-            <a:pPr indent="0" marL="0">
+            <a:pPr marL="0" indent="0" algn="l">
               <a:buNone/>
             </a:pPr>
-            <a:r>
-              <a:rPr lang="en-US" sz="1000" dirty="0">
-                <a:solidFill>
-                  <a:srgbClr val="5DCAA5"/>
-                </a:solidFill>
-                <a:latin typeface="Calibri" pitchFamily="34" charset="0"/>
-                <a:ea typeface="Calibri" pitchFamily="34" charset="-122"/>
-                <a:cs typeface="Calibri" pitchFamily="34" charset="-120"/>
-              </a:rPr>
-              <a:t>Frontend app</a:t>
-            </a:r>
             <a:endParaRPr lang="en-US" sz="1000" dirty="0"/>
           </a:p>
         </p:txBody>
@@ -1160,8 +1127,8 @@
         </p:nvSpPr>
         <p:spPr>
           <a:xfrm>
-            <a:off x="2240280" y="1325880"/>
-            <a:ext cx="2286000" cy="2194560"/>
+            <a:off x="2240280" y="1280160"/>
+            <a:ext cx="2331720" cy="2240280"/>
           </a:xfrm>
           <a:prstGeom prst="rect">
             <a:avLst/>
@@ -1171,11 +1138,18 @@
           </a:solidFill>
           <a:ln w="10160">
             <a:solidFill>
-              <a:srgbClr val="534AB7"/>
+              <a:srgbClr val="7F77DD"/>
             </a:solidFill>
             <a:prstDash val="sysDash"/>
           </a:ln>
         </p:spPr>
+        <p:txBody>
+          <a:bodyPr/>
+          <a:lstStyle/>
+          <a:p>
+            <a:endParaRPr lang="en-US"/>
+          </a:p>
+        </p:txBody>
       </p:sp>
       <p:sp>
         <p:nvSpPr>
@@ -1185,8 +1159,8 @@
         </p:nvSpPr>
         <p:spPr>
           <a:xfrm>
-            <a:off x="2286000" y="1371600"/>
-            <a:ext cx="2011680" cy="228600"/>
+            <a:off x="2304288" y="1335024"/>
+            <a:ext cx="2011680" cy="219456"/>
           </a:xfrm>
           <a:prstGeom prst="rect">
             <a:avLst/>
@@ -1198,7 +1172,7 @@
           <a:bodyPr wrap="square" lIns="0" tIns="0" rIns="0" bIns="0" rtlCol="0" anchor="ctr"/>
           <a:lstStyle/>
           <a:p>
-            <a:pPr indent="0" marL="0">
+            <a:pPr marL="0" indent="0" algn="l">
               <a:buNone/>
             </a:pPr>
             <a:r>
@@ -1224,14 +1198,14 @@
         </p:nvSpPr>
         <p:spPr>
           <a:xfrm>
-            <a:off x="2377440" y="1691640"/>
-            <a:ext cx="2011680" cy="822960"/>
-          </a:xfrm>
-          <a:prstGeom prst="rect">
-            <a:avLst/>
-          </a:prstGeom>
-          <a:solidFill>
-            <a:srgbClr val="1A2A44"/>
+            <a:off x="2359152" y="1645920"/>
+            <a:ext cx="2084832" cy="804672"/>
+          </a:xfrm>
+          <a:prstGeom prst="rect">
+            <a:avLst/>
+          </a:prstGeom>
+          <a:solidFill>
+            <a:srgbClr val="0E2233"/>
           </a:solidFill>
           <a:ln w="12700">
             <a:solidFill>
@@ -1239,14 +1213,14 @@
             </a:solidFill>
             <a:prstDash val="solid"/>
           </a:ln>
-          <a:effectLst>
-            <a:outerShdw sx="100000" sy="100000" kx="0" ky="0" algn="bl" rotWithShape="0" blurRad="101600" dist="38100" dir="8100000">
-              <a:srgbClr val="000000">
-                <a:alpha val="30000"/>
-              </a:srgbClr>
-            </a:outerShdw>
-          </a:effectLst>
-        </p:spPr>
+        </p:spPr>
+        <p:txBody>
+          <a:bodyPr/>
+          <a:lstStyle/>
+          <a:p>
+            <a:endParaRPr lang="en-US"/>
+          </a:p>
+        </p:txBody>
       </p:sp>
       <p:sp>
         <p:nvSpPr>
@@ -1256,8 +1230,8 @@
         </p:nvSpPr>
         <p:spPr>
           <a:xfrm>
-            <a:off x="2377440" y="1691640"/>
-            <a:ext cx="64008" cy="822960"/>
+            <a:off x="2359152" y="1645920"/>
+            <a:ext cx="64008" cy="804672"/>
           </a:xfrm>
           <a:prstGeom prst="rect">
             <a:avLst/>
@@ -1272,6 +1246,13 @@
             <a:prstDash val="solid"/>
           </a:ln>
         </p:spPr>
+        <p:txBody>
+          <a:bodyPr/>
+          <a:lstStyle/>
+          <a:p>
+            <a:endParaRPr lang="en-US"/>
+          </a:p>
+        </p:txBody>
       </p:sp>
       <p:sp>
         <p:nvSpPr>
@@ -1281,8 +1262,8 @@
         </p:nvSpPr>
         <p:spPr>
           <a:xfrm>
-            <a:off x="2514600" y="1783080"/>
-            <a:ext cx="1828800" cy="256032"/>
+            <a:off x="2487168" y="1728216"/>
+            <a:ext cx="1920240" cy="256032"/>
           </a:xfrm>
           <a:prstGeom prst="rect">
             <a:avLst/>
@@ -1294,7 +1275,7 @@
           <a:bodyPr wrap="square" lIns="0" tIns="0" rIns="0" bIns="0" rtlCol="0" anchor="ctr"/>
           <a:lstStyle/>
           <a:p>
-            <a:pPr indent="0" marL="0">
+            <a:pPr marL="0" indent="0" algn="l">
               <a:buNone/>
             </a:pPr>
             <a:r>
@@ -1320,8 +1301,8 @@
         </p:nvSpPr>
         <p:spPr>
           <a:xfrm>
-            <a:off x="2514600" y="2011680"/>
-            <a:ext cx="1828800" cy="201168"/>
+            <a:off x="2487168" y="1984248"/>
+            <a:ext cx="1920240" cy="201168"/>
           </a:xfrm>
           <a:prstGeom prst="rect">
             <a:avLst/>
@@ -1333,7 +1314,7 @@
           <a:bodyPr wrap="square" lIns="0" tIns="0" rIns="0" bIns="0" rtlCol="0" anchor="ctr"/>
           <a:lstStyle/>
           <a:p>
-            <a:pPr indent="0" marL="0">
+            <a:pPr marL="0" indent="0" algn="l">
               <a:buNone/>
             </a:pPr>
             <a:r>
@@ -1359,14 +1340,14 @@
         </p:nvSpPr>
         <p:spPr>
           <a:xfrm>
-            <a:off x="4937760" y="1325880"/>
-            <a:ext cx="3474720" cy="685800"/>
-          </a:xfrm>
-          <a:prstGeom prst="rect">
-            <a:avLst/>
-          </a:prstGeom>
-          <a:solidFill>
-            <a:srgbClr val="1F1A0A"/>
+            <a:off x="4978908" y="2090928"/>
+            <a:ext cx="3520440" cy="658368"/>
+          </a:xfrm>
+          <a:prstGeom prst="rect">
+            <a:avLst/>
+          </a:prstGeom>
+          <a:solidFill>
+            <a:srgbClr val="1E1505"/>
           </a:solidFill>
           <a:ln w="12700">
             <a:solidFill>
@@ -1374,14 +1355,14 @@
             </a:solidFill>
             <a:prstDash val="solid"/>
           </a:ln>
-          <a:effectLst>
-            <a:outerShdw sx="100000" sy="100000" kx="0" ky="0" algn="bl" rotWithShape="0" blurRad="101600" dist="38100" dir="8100000">
-              <a:srgbClr val="000000">
-                <a:alpha val="30000"/>
-              </a:srgbClr>
-            </a:outerShdw>
-          </a:effectLst>
-        </p:spPr>
+        </p:spPr>
+        <p:txBody>
+          <a:bodyPr/>
+          <a:lstStyle/>
+          <a:p>
+            <a:endParaRPr lang="en-US"/>
+          </a:p>
+        </p:txBody>
       </p:sp>
       <p:sp>
         <p:nvSpPr>
@@ -1391,8 +1372,8 @@
         </p:nvSpPr>
         <p:spPr>
           <a:xfrm>
-            <a:off x="4937760" y="1325880"/>
-            <a:ext cx="64008" cy="685800"/>
+            <a:off x="4974336" y="2101596"/>
+            <a:ext cx="64008" cy="658368"/>
           </a:xfrm>
           <a:prstGeom prst="rect">
             <a:avLst/>
@@ -1407,6 +1388,13 @@
             <a:prstDash val="solid"/>
           </a:ln>
         </p:spPr>
+        <p:txBody>
+          <a:bodyPr/>
+          <a:lstStyle/>
+          <a:p>
+            <a:endParaRPr lang="en-US"/>
+          </a:p>
+        </p:txBody>
       </p:sp>
       <p:sp>
         <p:nvSpPr>
@@ -1416,8 +1404,8 @@
         </p:nvSpPr>
         <p:spPr>
           <a:xfrm>
-            <a:off x="5074920" y="1417320"/>
-            <a:ext cx="3291840" cy="256032"/>
+            <a:off x="5102352" y="2183892"/>
+            <a:ext cx="3355848" cy="256032"/>
           </a:xfrm>
           <a:prstGeom prst="rect">
             <a:avLst/>
@@ -1429,7 +1417,7 @@
           <a:bodyPr wrap="square" lIns="0" tIns="0" rIns="0" bIns="0" rtlCol="0" anchor="ctr"/>
           <a:lstStyle/>
           <a:p>
-            <a:pPr indent="0" marL="0">
+            <a:pPr marL="0" indent="0" algn="l">
               <a:buNone/>
             </a:pPr>
             <a:r>
@@ -1455,8 +1443,8 @@
         </p:nvSpPr>
         <p:spPr>
           <a:xfrm>
-            <a:off x="5074920" y="1645920"/>
-            <a:ext cx="3291840" cy="201168"/>
+            <a:off x="5102352" y="2439924"/>
+            <a:ext cx="3355848" cy="201168"/>
           </a:xfrm>
           <a:prstGeom prst="rect">
             <a:avLst/>
@@ -1468,7 +1456,7 @@
           <a:bodyPr wrap="square" lIns="0" tIns="0" rIns="0" bIns="0" rtlCol="0" anchor="ctr"/>
           <a:lstStyle/>
           <a:p>
-            <a:pPr indent="0" marL="0">
+            <a:pPr marL="0" indent="0" algn="l">
               <a:buNone/>
             </a:pPr>
             <a:r>
@@ -1494,14 +1482,14 @@
         </p:nvSpPr>
         <p:spPr>
           <a:xfrm>
-            <a:off x="4937760" y="2240280"/>
-            <a:ext cx="3474720" cy="685800"/>
-          </a:xfrm>
-          <a:prstGeom prst="rect">
-            <a:avLst/>
-          </a:prstGeom>
-          <a:solidFill>
-            <a:srgbClr val="1A0F14"/>
+            <a:off x="4960620" y="1137365"/>
+            <a:ext cx="3520440" cy="658368"/>
+          </a:xfrm>
+          <a:prstGeom prst="rect">
+            <a:avLst/>
+          </a:prstGeom>
+          <a:solidFill>
+            <a:srgbClr val="1A0D14"/>
           </a:solidFill>
           <a:ln w="12700">
             <a:solidFill>
@@ -1509,14 +1497,14 @@
             </a:solidFill>
             <a:prstDash val="solid"/>
           </a:ln>
-          <a:effectLst>
-            <a:outerShdw sx="100000" sy="100000" kx="0" ky="0" algn="bl" rotWithShape="0" blurRad="101600" dist="38100" dir="8100000">
-              <a:srgbClr val="000000">
-                <a:alpha val="30000"/>
-              </a:srgbClr>
-            </a:outerShdw>
-          </a:effectLst>
-        </p:spPr>
+        </p:spPr>
+        <p:txBody>
+          <a:bodyPr/>
+          <a:lstStyle/>
+          <a:p>
+            <a:endParaRPr lang="en-US"/>
+          </a:p>
+        </p:txBody>
       </p:sp>
       <p:sp>
         <p:nvSpPr>
@@ -1526,8 +1514,8 @@
         </p:nvSpPr>
         <p:spPr>
           <a:xfrm>
-            <a:off x="4937760" y="2240280"/>
-            <a:ext cx="64008" cy="685800"/>
+            <a:off x="4963386" y="1133856"/>
+            <a:ext cx="64008" cy="658368"/>
           </a:xfrm>
           <a:prstGeom prst="rect">
             <a:avLst/>
@@ -1542,6 +1530,13 @@
             <a:prstDash val="solid"/>
           </a:ln>
         </p:spPr>
+        <p:txBody>
+          <a:bodyPr/>
+          <a:lstStyle/>
+          <a:p>
+            <a:endParaRPr lang="en-US"/>
+          </a:p>
+        </p:txBody>
       </p:sp>
       <p:sp>
         <p:nvSpPr>
@@ -1551,8 +1546,8 @@
         </p:nvSpPr>
         <p:spPr>
           <a:xfrm>
-            <a:off x="5074920" y="2331720"/>
-            <a:ext cx="3291840" cy="256032"/>
+            <a:off x="5088636" y="1365965"/>
+            <a:ext cx="3355848" cy="256032"/>
           </a:xfrm>
           <a:prstGeom prst="rect">
             <a:avLst/>
@@ -1564,7 +1559,7 @@
           <a:bodyPr wrap="square" lIns="0" tIns="0" rIns="0" bIns="0" rtlCol="0" anchor="ctr"/>
           <a:lstStyle/>
           <a:p>
-            <a:pPr indent="0" marL="0">
+            <a:pPr marL="0" indent="0" algn="l">
               <a:buNone/>
             </a:pPr>
             <a:r>
@@ -1590,8 +1585,8 @@
         </p:nvSpPr>
         <p:spPr>
           <a:xfrm>
-            <a:off x="5074920" y="2560320"/>
-            <a:ext cx="3291840" cy="201168"/>
+            <a:off x="5088636" y="1621997"/>
+            <a:ext cx="3355848" cy="201168"/>
           </a:xfrm>
           <a:prstGeom prst="rect">
             <a:avLst/>
@@ -1603,7 +1598,7 @@
           <a:bodyPr wrap="square" lIns="0" tIns="0" rIns="0" bIns="0" rtlCol="0" anchor="ctr"/>
           <a:lstStyle/>
           <a:p>
-            <a:pPr indent="0" marL="0">
+            <a:pPr marL="0" indent="0" algn="l">
               <a:buNone/>
             </a:pPr>
             <a:r>
@@ -1629,8 +1624,8 @@
         </p:nvSpPr>
         <p:spPr>
           <a:xfrm>
-            <a:off x="4937760" y="3154680"/>
-            <a:ext cx="3474720" cy="685800"/>
+            <a:off x="4983480" y="3054096"/>
+            <a:ext cx="3520440" cy="658368"/>
           </a:xfrm>
           <a:prstGeom prst="rect">
             <a:avLst/>
@@ -1644,14 +1639,14 @@
             </a:solidFill>
             <a:prstDash val="solid"/>
           </a:ln>
-          <a:effectLst>
-            <a:outerShdw sx="100000" sy="100000" kx="0" ky="0" algn="bl" rotWithShape="0" blurRad="101600" dist="38100" dir="8100000">
-              <a:srgbClr val="000000">
-                <a:alpha val="30000"/>
-              </a:srgbClr>
-            </a:outerShdw>
-          </a:effectLst>
-        </p:spPr>
+        </p:spPr>
+        <p:txBody>
+          <a:bodyPr/>
+          <a:lstStyle/>
+          <a:p>
+            <a:endParaRPr lang="en-US"/>
+          </a:p>
+        </p:txBody>
       </p:sp>
       <p:sp>
         <p:nvSpPr>
@@ -1661,8 +1656,8 @@
         </p:nvSpPr>
         <p:spPr>
           <a:xfrm>
-            <a:off x="4937760" y="3154680"/>
-            <a:ext cx="64008" cy="685800"/>
+            <a:off x="4983480" y="3054096"/>
+            <a:ext cx="64008" cy="658368"/>
           </a:xfrm>
           <a:prstGeom prst="rect">
             <a:avLst/>
@@ -1677,6 +1672,13 @@
             <a:prstDash val="solid"/>
           </a:ln>
         </p:spPr>
+        <p:txBody>
+          <a:bodyPr/>
+          <a:lstStyle/>
+          <a:p>
+            <a:endParaRPr lang="en-US"/>
+          </a:p>
+        </p:txBody>
       </p:sp>
       <p:sp>
         <p:nvSpPr>
@@ -1686,8 +1688,8 @@
         </p:nvSpPr>
         <p:spPr>
           <a:xfrm>
-            <a:off x="5074920" y="3246120"/>
-            <a:ext cx="3291840" cy="256032"/>
+            <a:off x="5111496" y="3136392"/>
+            <a:ext cx="3355848" cy="256032"/>
           </a:xfrm>
           <a:prstGeom prst="rect">
             <a:avLst/>
@@ -1699,7 +1701,7 @@
           <a:bodyPr wrap="square" lIns="0" tIns="0" rIns="0" bIns="0" rtlCol="0" anchor="ctr"/>
           <a:lstStyle/>
           <a:p>
-            <a:pPr indent="0" marL="0">
+            <a:pPr marL="0" indent="0" algn="l">
               <a:buNone/>
             </a:pPr>
             <a:r>
@@ -1725,8 +1727,8 @@
         </p:nvSpPr>
         <p:spPr>
           <a:xfrm>
-            <a:off x="5074920" y="3474720"/>
-            <a:ext cx="3291840" cy="201168"/>
+            <a:off x="5111496" y="3392424"/>
+            <a:ext cx="3355848" cy="201168"/>
           </a:xfrm>
           <a:prstGeom prst="rect">
             <a:avLst/>
@@ -1738,7 +1740,7 @@
           <a:bodyPr wrap="square" lIns="0" tIns="0" rIns="0" bIns="0" rtlCol="0" anchor="ctr"/>
           <a:lstStyle/>
           <a:p>
-            <a:pPr indent="0" marL="0">
+            <a:pPr marL="0" indent="0" algn="l">
               <a:buNone/>
             </a:pPr>
             <a:r>
@@ -1764,14 +1766,14 @@
         </p:nvSpPr>
         <p:spPr>
           <a:xfrm>
-            <a:off x="2240280" y="3977640"/>
-            <a:ext cx="6492240" cy="502920"/>
-          </a:xfrm>
-          <a:prstGeom prst="rect">
-            <a:avLst/>
-          </a:prstGeom>
-          <a:solidFill>
-            <a:srgbClr val="0C1520"/>
+            <a:off x="2240280" y="3931920"/>
+            <a:ext cx="6263640" cy="475488"/>
+          </a:xfrm>
+          <a:prstGeom prst="rect">
+            <a:avLst/>
+          </a:prstGeom>
+          <a:solidFill>
+            <a:srgbClr val="0A1520"/>
           </a:solidFill>
           <a:ln w="7620">
             <a:solidFill>
@@ -1780,6 +1782,13 @@
             <a:prstDash val="dash"/>
           </a:ln>
         </p:spPr>
+        <p:txBody>
+          <a:bodyPr/>
+          <a:lstStyle/>
+          <a:p>
+            <a:endParaRPr lang="en-US"/>
+          </a:p>
+        </p:txBody>
       </p:sp>
       <p:sp>
         <p:nvSpPr>
@@ -1789,8 +1798,8 @@
         </p:nvSpPr>
         <p:spPr>
           <a:xfrm>
-            <a:off x="2331720" y="4023360"/>
-            <a:ext cx="6309360" cy="320040"/>
+            <a:off x="2286000" y="3977640"/>
+            <a:ext cx="6172200" cy="320040"/>
           </a:xfrm>
           <a:prstGeom prst="rect">
             <a:avLst/>
@@ -1802,13 +1811,13 @@
           <a:bodyPr wrap="square" lIns="0" tIns="0" rIns="0" bIns="0" rtlCol="0" anchor="ctr"/>
           <a:lstStyle/>
           <a:p>
-            <a:pPr algn="ctr" indent="0" marL="0">
+            <a:pPr marL="0" indent="0" algn="ctr">
               <a:buNone/>
             </a:pPr>
             <a:r>
               <a:rPr lang="en-US" sz="1100" i="1" dirty="0">
                 <a:solidFill>
-                  <a:srgbClr val="6B8BAE"/>
+                  <a:srgbClr val="5A7A9A"/>
                 </a:solidFill>
                 <a:latin typeface="Calibri" pitchFamily="34" charset="0"/>
                 <a:ea typeface="Calibri" pitchFamily="34" charset="-122"/>
@@ -1822,38 +1831,14 @@
       </p:sp>
       <p:sp>
         <p:nvSpPr>
-          <p:cNvPr id="30" name="Shape 28"/>
-          <p:cNvSpPr/>
-          <p:nvPr/>
-        </p:nvSpPr>
-        <p:spPr>
-          <a:xfrm>
-            <a:off x="1874520" y="2112264"/>
-            <a:ext cx="365760" cy="0"/>
-          </a:xfrm>
-          <a:prstGeom prst="line">
-            <a:avLst/>
-          </a:prstGeom>
-          <a:noFill/>
-          <a:ln w="19050">
-            <a:solidFill>
-              <a:srgbClr val="1D9E75"/>
-            </a:solidFill>
-            <a:prstDash val="solid"/>
-            <a:tailEnd type="open"/>
-          </a:ln>
-        </p:spPr>
-      </p:sp>
-      <p:sp>
-        <p:nvSpPr>
-          <p:cNvPr id="31" name="Text 29"/>
-          <p:cNvSpPr/>
-          <p:nvPr/>
-        </p:nvSpPr>
-        <p:spPr>
-          <a:xfrm>
-            <a:off x="1828800" y="1938528"/>
-            <a:ext cx="502920" cy="201168"/>
+          <p:cNvPr id="30" name="Text 28"/>
+          <p:cNvSpPr/>
+          <p:nvPr/>
+        </p:nvSpPr>
+        <p:spPr>
+          <a:xfrm>
+            <a:off x="1796796" y="2953512"/>
+            <a:ext cx="457200" cy="201168"/>
           </a:xfrm>
           <a:prstGeom prst="rect">
             <a:avLst/>
@@ -1865,11 +1850,11 @@
           <a:bodyPr wrap="square" lIns="0" tIns="0" rIns="0" bIns="0" rtlCol="0" anchor="ctr"/>
           <a:lstStyle/>
           <a:p>
-            <a:pPr algn="ctr" indent="0" marL="0">
+            <a:pPr marL="0" indent="0" algn="ctr">
               <a:buNone/>
             </a:pPr>
             <a:r>
-              <a:rPr lang="en-US" sz="800" dirty="0">
+              <a:rPr lang="en-US" sz="900" dirty="0">
                 <a:solidFill>
                   <a:srgbClr val="1D9E75"/>
                 </a:solidFill>
@@ -1877,46 +1862,22 @@
                 <a:ea typeface="Calibri" pitchFamily="34" charset="-122"/>
                 <a:cs typeface="Calibri" pitchFamily="34" charset="-120"/>
               </a:rPr>
-              <a:t>HTTP</a:t>
+              <a:t>HTTP →</a:t>
             </a:r>
-            <a:endParaRPr lang="en-US" sz="800" dirty="0"/>
-          </a:p>
-        </p:txBody>
-      </p:sp>
-      <p:sp>
-        <p:nvSpPr>
-          <p:cNvPr id="32" name="Shape 30"/>
-          <p:cNvSpPr/>
-          <p:nvPr/>
-        </p:nvSpPr>
-        <p:spPr>
-          <a:xfrm>
-            <a:off x="4389120" y="1664208"/>
-            <a:ext cx="548640" cy="0"/>
-          </a:xfrm>
-          <a:prstGeom prst="line">
-            <a:avLst/>
-          </a:prstGeom>
-          <a:noFill/>
-          <a:ln w="19050">
-            <a:solidFill>
-              <a:srgbClr val="EF9F27"/>
-            </a:solidFill>
-            <a:prstDash val="solid"/>
-            <a:tailEnd type="open"/>
-          </a:ln>
-        </p:spPr>
-      </p:sp>
-      <p:sp>
-        <p:nvSpPr>
-          <p:cNvPr id="33" name="Text 31"/>
-          <p:cNvSpPr/>
-          <p:nvPr/>
-        </p:nvSpPr>
-        <p:spPr>
-          <a:xfrm>
-            <a:off x="4407408" y="1508760"/>
-            <a:ext cx="502920" cy="182880"/>
+            <a:endParaRPr lang="en-US" sz="900" dirty="0"/>
+          </a:p>
+        </p:txBody>
+      </p:sp>
+      <p:sp>
+        <p:nvSpPr>
+          <p:cNvPr id="31" name="Text 29"/>
+          <p:cNvSpPr/>
+          <p:nvPr/>
+        </p:nvSpPr>
+        <p:spPr>
+          <a:xfrm>
+            <a:off x="4304538" y="2524898"/>
+            <a:ext cx="640080" cy="182880"/>
           </a:xfrm>
           <a:prstGeom prst="rect">
             <a:avLst/>
@@ -1928,11 +1889,11 @@
           <a:bodyPr wrap="square" lIns="0" tIns="0" rIns="0" bIns="0" rtlCol="0" anchor="ctr"/>
           <a:lstStyle/>
           <a:p>
-            <a:pPr algn="ctr" indent="0" marL="0">
+            <a:pPr marL="0" indent="0" algn="ctr">
               <a:buNone/>
             </a:pPr>
             <a:r>
-              <a:rPr lang="en-US" sz="800" dirty="0">
+              <a:rPr lang="en-US" sz="900" dirty="0">
                 <a:solidFill>
                   <a:srgbClr val="EF9F27"/>
                 </a:solidFill>
@@ -1940,46 +1901,22 @@
                 <a:ea typeface="Calibri" pitchFamily="34" charset="-122"/>
                 <a:cs typeface="Calibri" pitchFamily="34" charset="-120"/>
               </a:rPr>
-              <a:t>query</a:t>
+              <a:t>query →</a:t>
             </a:r>
-            <a:endParaRPr lang="en-US" sz="800" dirty="0"/>
-          </a:p>
-        </p:txBody>
-      </p:sp>
-      <p:sp>
-        <p:nvSpPr>
-          <p:cNvPr id="34" name="Shape 32"/>
-          <p:cNvSpPr/>
-          <p:nvPr/>
-        </p:nvSpPr>
-        <p:spPr>
-          <a:xfrm>
-            <a:off x="4389120" y="2578608"/>
-            <a:ext cx="548640" cy="0"/>
-          </a:xfrm>
-          <a:prstGeom prst="line">
-            <a:avLst/>
-          </a:prstGeom>
-          <a:noFill/>
-          <a:ln w="19050">
-            <a:solidFill>
-              <a:srgbClr val="D4537E"/>
-            </a:solidFill>
-            <a:prstDash val="solid"/>
-            <a:tailEnd type="open"/>
-          </a:ln>
-        </p:spPr>
-      </p:sp>
-      <p:sp>
-        <p:nvSpPr>
-          <p:cNvPr id="35" name="Text 33"/>
-          <p:cNvSpPr/>
-          <p:nvPr/>
-        </p:nvSpPr>
-        <p:spPr>
-          <a:xfrm>
-            <a:off x="4407408" y="2423160"/>
-            <a:ext cx="502920" cy="182880"/>
+            <a:endParaRPr lang="en-US" sz="900" dirty="0"/>
+          </a:p>
+        </p:txBody>
+      </p:sp>
+      <p:sp>
+        <p:nvSpPr>
+          <p:cNvPr id="32" name="Text 30"/>
+          <p:cNvSpPr/>
+          <p:nvPr/>
+        </p:nvSpPr>
+        <p:spPr>
+          <a:xfrm>
+            <a:off x="4315968" y="1353312"/>
+            <a:ext cx="658368" cy="182880"/>
           </a:xfrm>
           <a:prstGeom prst="rect">
             <a:avLst/>
@@ -1991,11 +1928,11 @@
           <a:bodyPr wrap="square" lIns="0" tIns="0" rIns="0" bIns="0" rtlCol="0" anchor="ctr"/>
           <a:lstStyle/>
           <a:p>
-            <a:pPr algn="ctr" indent="0" marL="0">
+            <a:pPr marL="0" indent="0" algn="ctr">
               <a:buNone/>
             </a:pPr>
             <a:r>
-              <a:rPr lang="en-US" sz="800" dirty="0">
+              <a:rPr lang="en-US" sz="900" dirty="0">
                 <a:solidFill>
                   <a:srgbClr val="D4537E"/>
                 </a:solidFill>
@@ -2003,7 +1940,46 @@
                 <a:ea typeface="Calibri" pitchFamily="34" charset="-122"/>
                 <a:cs typeface="Calibri" pitchFamily="34" charset="-120"/>
               </a:rPr>
-              <a:t>upload</a:t>
+              <a:t>upload →</a:t>
+            </a:r>
+            <a:endParaRPr lang="en-US" sz="900" dirty="0"/>
+          </a:p>
+        </p:txBody>
+      </p:sp>
+      <p:sp>
+        <p:nvSpPr>
+          <p:cNvPr id="33" name="Text 31"/>
+          <p:cNvSpPr/>
+          <p:nvPr/>
+        </p:nvSpPr>
+        <p:spPr>
+          <a:xfrm>
+            <a:off x="4846320" y="2907792"/>
+            <a:ext cx="1188720" cy="182880"/>
+          </a:xfrm>
+          <a:prstGeom prst="rect">
+            <a:avLst/>
+          </a:prstGeom>
+          <a:noFill/>
+          <a:ln/>
+        </p:spPr>
+        <p:txBody>
+          <a:bodyPr wrap="square" lIns="0" tIns="0" rIns="0" bIns="0" rtlCol="0" anchor="ctr"/>
+          <a:lstStyle/>
+          <a:p>
+            <a:pPr marL="0" indent="0" algn="l">
+              <a:buNone/>
+            </a:pPr>
+            <a:r>
+              <a:rPr lang="en-US" sz="800" dirty="0">
+                <a:solidFill>
+                  <a:srgbClr val="888780"/>
+                </a:solidFill>
+                <a:latin typeface="Calibri" pitchFamily="34" charset="0"/>
+                <a:ea typeface="Calibri" pitchFamily="34" charset="-122"/>
+                <a:cs typeface="Calibri" pitchFamily="34" charset="-120"/>
+              </a:rPr>
+              <a:t>grants access ↗</a:t>
             </a:r>
             <a:endParaRPr lang="en-US" sz="800" dirty="0"/>
           </a:p>
@@ -2011,38 +1987,14 @@
       </p:sp>
       <p:sp>
         <p:nvSpPr>
-          <p:cNvPr id="36" name="Shape 34"/>
-          <p:cNvSpPr/>
-          <p:nvPr/>
-        </p:nvSpPr>
-        <p:spPr>
-          <a:xfrm>
-            <a:off x="4937760" y="3154680"/>
-            <a:ext cx="0" cy="-228600"/>
-          </a:xfrm>
-          <a:prstGeom prst="line">
-            <a:avLst/>
-          </a:prstGeom>
-          <a:noFill/>
-          <a:ln w="12700">
-            <a:solidFill>
-              <a:srgbClr val="888780"/>
-            </a:solidFill>
-            <a:prstDash val="dash"/>
-            <a:tailEnd type="open"/>
-          </a:ln>
-        </p:spPr>
-      </p:sp>
-      <p:sp>
-        <p:nvSpPr>
-          <p:cNvPr id="37" name="Shape 35"/>
-          <p:cNvSpPr/>
-          <p:nvPr/>
-        </p:nvSpPr>
-        <p:spPr>
-          <a:xfrm>
-            <a:off x="182880" y="4645152"/>
-            <a:ext cx="1645920" cy="237744"/>
+          <p:cNvPr id="34" name="Shape 32"/>
+          <p:cNvSpPr/>
+          <p:nvPr/>
+        </p:nvSpPr>
+        <p:spPr>
+          <a:xfrm>
+            <a:off x="137160" y="4663440"/>
+            <a:ext cx="1645920" cy="228600"/>
           </a:xfrm>
           <a:prstGeom prst="rect">
             <a:avLst/>
@@ -2050,24 +2002,31 @@
           <a:solidFill>
             <a:srgbClr val="0D1B2A"/>
           </a:solidFill>
-          <a:ln w="7620">
+          <a:ln w="8890">
             <a:solidFill>
               <a:srgbClr val="AFA9EC"/>
             </a:solidFill>
             <a:prstDash val="solid"/>
           </a:ln>
         </p:spPr>
-      </p:sp>
-      <p:sp>
-        <p:nvSpPr>
-          <p:cNvPr id="38" name="Text 36"/>
-          <p:cNvSpPr/>
-          <p:nvPr/>
-        </p:nvSpPr>
-        <p:spPr>
-          <a:xfrm>
-            <a:off x="201168" y="4663440"/>
-            <a:ext cx="1609344" cy="201168"/>
+        <p:txBody>
+          <a:bodyPr/>
+          <a:lstStyle/>
+          <a:p>
+            <a:endParaRPr lang="en-US"/>
+          </a:p>
+        </p:txBody>
+      </p:sp>
+      <p:sp>
+        <p:nvSpPr>
+          <p:cNvPr id="35" name="Text 33"/>
+          <p:cNvSpPr/>
+          <p:nvPr/>
+        </p:nvSpPr>
+        <p:spPr>
+          <a:xfrm>
+            <a:off x="155448" y="4681728"/>
+            <a:ext cx="1609344" cy="192024"/>
           </a:xfrm>
           <a:prstGeom prst="rect">
             <a:avLst/>
@@ -2079,7 +2038,7 @@
           <a:bodyPr wrap="square" lIns="0" tIns="0" rIns="0" bIns="0" rtlCol="0" anchor="ctr"/>
           <a:lstStyle/>
           <a:p>
-            <a:pPr algn="ctr" indent="0" marL="0">
+            <a:pPr marL="0" indent="0" algn="ctr">
               <a:buNone/>
             </a:pPr>
             <a:r>
@@ -2091,7 +2050,7 @@
                 <a:ea typeface="Calibri" pitchFamily="34" charset="-122"/>
                 <a:cs typeface="Calibri" pitchFamily="34" charset="-120"/>
               </a:rPr>
-              <a:t>Wk 2-3: EC2</a:t>
+              <a:t>EC2</a:t>
             </a:r>
             <a:endParaRPr lang="en-US" sz="900" dirty="0"/>
           </a:p>
@@ -2099,14 +2058,14 @@
       </p:sp>
       <p:sp>
         <p:nvSpPr>
-          <p:cNvPr id="39" name="Shape 37"/>
-          <p:cNvSpPr/>
-          <p:nvPr/>
-        </p:nvSpPr>
-        <p:spPr>
-          <a:xfrm>
-            <a:off x="1965960" y="4645152"/>
-            <a:ext cx="1645920" cy="237744"/>
+          <p:cNvPr id="36" name="Shape 34"/>
+          <p:cNvSpPr/>
+          <p:nvPr/>
+        </p:nvSpPr>
+        <p:spPr>
+          <a:xfrm>
+            <a:off x="1911096" y="4663440"/>
+            <a:ext cx="1645920" cy="228600"/>
           </a:xfrm>
           <a:prstGeom prst="rect">
             <a:avLst/>
@@ -2114,24 +2073,31 @@
           <a:solidFill>
             <a:srgbClr val="0D1B2A"/>
           </a:solidFill>
-          <a:ln w="7620">
+          <a:ln w="8890">
             <a:solidFill>
               <a:srgbClr val="5DCAA5"/>
             </a:solidFill>
             <a:prstDash val="solid"/>
           </a:ln>
         </p:spPr>
-      </p:sp>
-      <p:sp>
-        <p:nvSpPr>
-          <p:cNvPr id="40" name="Text 38"/>
-          <p:cNvSpPr/>
-          <p:nvPr/>
-        </p:nvSpPr>
-        <p:spPr>
-          <a:xfrm>
-            <a:off x="1984248" y="4663440"/>
-            <a:ext cx="1609344" cy="201168"/>
+        <p:txBody>
+          <a:bodyPr/>
+          <a:lstStyle/>
+          <a:p>
+            <a:endParaRPr lang="en-US"/>
+          </a:p>
+        </p:txBody>
+      </p:sp>
+      <p:sp>
+        <p:nvSpPr>
+          <p:cNvPr id="37" name="Text 35"/>
+          <p:cNvSpPr/>
+          <p:nvPr/>
+        </p:nvSpPr>
+        <p:spPr>
+          <a:xfrm>
+            <a:off x="1929384" y="4681728"/>
+            <a:ext cx="1609344" cy="192024"/>
           </a:xfrm>
           <a:prstGeom prst="rect">
             <a:avLst/>
@@ -2143,7 +2109,7 @@
           <a:bodyPr wrap="square" lIns="0" tIns="0" rIns="0" bIns="0" rtlCol="0" anchor="ctr"/>
           <a:lstStyle/>
           <a:p>
-            <a:pPr algn="ctr" indent="0" marL="0">
+            <a:pPr marL="0" indent="0" algn="ctr">
               <a:buNone/>
             </a:pPr>
             <a:r>
@@ -2155,7 +2121,7 @@
                 <a:ea typeface="Calibri" pitchFamily="34" charset="-122"/>
                 <a:cs typeface="Calibri" pitchFamily="34" charset="-120"/>
               </a:rPr>
-              <a:t>Wk 4: Docker</a:t>
+              <a:t>Docker</a:t>
             </a:r>
             <a:endParaRPr lang="en-US" sz="900" dirty="0"/>
           </a:p>
@@ -2163,14 +2129,14 @@
       </p:sp>
       <p:sp>
         <p:nvSpPr>
-          <p:cNvPr id="41" name="Shape 39"/>
-          <p:cNvSpPr/>
-          <p:nvPr/>
-        </p:nvSpPr>
-        <p:spPr>
-          <a:xfrm>
-            <a:off x="3749040" y="4645152"/>
-            <a:ext cx="1645920" cy="237744"/>
+          <p:cNvPr id="38" name="Shape 36"/>
+          <p:cNvSpPr/>
+          <p:nvPr/>
+        </p:nvSpPr>
+        <p:spPr>
+          <a:xfrm>
+            <a:off x="3685032" y="4663440"/>
+            <a:ext cx="1645920" cy="228600"/>
           </a:xfrm>
           <a:prstGeom prst="rect">
             <a:avLst/>
@@ -2178,24 +2144,31 @@
           <a:solidFill>
             <a:srgbClr val="0D1B2A"/>
           </a:solidFill>
-          <a:ln w="7620">
+          <a:ln w="8890">
             <a:solidFill>
               <a:srgbClr val="FAC775"/>
             </a:solidFill>
             <a:prstDash val="solid"/>
           </a:ln>
         </p:spPr>
-      </p:sp>
-      <p:sp>
-        <p:nvSpPr>
-          <p:cNvPr id="42" name="Text 40"/>
-          <p:cNvSpPr/>
-          <p:nvPr/>
-        </p:nvSpPr>
-        <p:spPr>
-          <a:xfrm>
-            <a:off x="3767328" y="4663440"/>
-            <a:ext cx="1609344" cy="201168"/>
+        <p:txBody>
+          <a:bodyPr/>
+          <a:lstStyle/>
+          <a:p>
+            <a:endParaRPr lang="en-US"/>
+          </a:p>
+        </p:txBody>
+      </p:sp>
+      <p:sp>
+        <p:nvSpPr>
+          <p:cNvPr id="39" name="Text 37"/>
+          <p:cNvSpPr/>
+          <p:nvPr/>
+        </p:nvSpPr>
+        <p:spPr>
+          <a:xfrm>
+            <a:off x="3703320" y="4681728"/>
+            <a:ext cx="1609344" cy="192024"/>
           </a:xfrm>
           <a:prstGeom prst="rect">
             <a:avLst/>
@@ -2207,7 +2180,7 @@
           <a:bodyPr wrap="square" lIns="0" tIns="0" rIns="0" bIns="0" rtlCol="0" anchor="ctr"/>
           <a:lstStyle/>
           <a:p>
-            <a:pPr algn="ctr" indent="0" marL="0">
+            <a:pPr marL="0" indent="0" algn="ctr">
               <a:buNone/>
             </a:pPr>
             <a:r>
@@ -2219,7 +2192,7 @@
                 <a:ea typeface="Calibri" pitchFamily="34" charset="-122"/>
                 <a:cs typeface="Calibri" pitchFamily="34" charset="-120"/>
               </a:rPr>
-              <a:t>Wk 5: RDS</a:t>
+              <a:t>RDS</a:t>
             </a:r>
             <a:endParaRPr lang="en-US" sz="900" dirty="0"/>
           </a:p>
@@ -2227,14 +2200,14 @@
       </p:sp>
       <p:sp>
         <p:nvSpPr>
-          <p:cNvPr id="43" name="Shape 41"/>
-          <p:cNvSpPr/>
-          <p:nvPr/>
-        </p:nvSpPr>
-        <p:spPr>
-          <a:xfrm>
-            <a:off x="5532120" y="4645152"/>
-            <a:ext cx="1645920" cy="237744"/>
+          <p:cNvPr id="40" name="Shape 38"/>
+          <p:cNvSpPr/>
+          <p:nvPr/>
+        </p:nvSpPr>
+        <p:spPr>
+          <a:xfrm>
+            <a:off x="5458968" y="4663440"/>
+            <a:ext cx="1645920" cy="228600"/>
           </a:xfrm>
           <a:prstGeom prst="rect">
             <a:avLst/>
@@ -2242,24 +2215,31 @@
           <a:solidFill>
             <a:srgbClr val="0D1B2A"/>
           </a:solidFill>
-          <a:ln w="7620">
+          <a:ln w="8890">
             <a:solidFill>
               <a:srgbClr val="6B8BAE"/>
             </a:solidFill>
             <a:prstDash val="solid"/>
           </a:ln>
         </p:spPr>
-      </p:sp>
-      <p:sp>
-        <p:nvSpPr>
-          <p:cNvPr id="44" name="Text 42"/>
-          <p:cNvSpPr/>
-          <p:nvPr/>
-        </p:nvSpPr>
-        <p:spPr>
-          <a:xfrm>
-            <a:off x="5550408" y="4663440"/>
-            <a:ext cx="1609344" cy="201168"/>
+        <p:txBody>
+          <a:bodyPr/>
+          <a:lstStyle/>
+          <a:p>
+            <a:endParaRPr lang="en-US"/>
+          </a:p>
+        </p:txBody>
+      </p:sp>
+      <p:sp>
+        <p:nvSpPr>
+          <p:cNvPr id="41" name="Text 39"/>
+          <p:cNvSpPr/>
+          <p:nvPr/>
+        </p:nvSpPr>
+        <p:spPr>
+          <a:xfrm>
+            <a:off x="5477256" y="4681728"/>
+            <a:ext cx="1609344" cy="192024"/>
           </a:xfrm>
           <a:prstGeom prst="rect">
             <a:avLst/>
@@ -2271,7 +2251,7 @@
           <a:bodyPr wrap="square" lIns="0" tIns="0" rIns="0" bIns="0" rtlCol="0" anchor="ctr"/>
           <a:lstStyle/>
           <a:p>
-            <a:pPr algn="ctr" indent="0" marL="0">
+            <a:pPr marL="0" indent="0" algn="ctr">
               <a:buNone/>
             </a:pPr>
             <a:r>
@@ -2283,7 +2263,7 @@
                 <a:ea typeface="Calibri" pitchFamily="34" charset="-122"/>
                 <a:cs typeface="Calibri" pitchFamily="34" charset="-120"/>
               </a:rPr>
-              <a:t>Wk 6: Terraform</a:t>
+              <a:t>Terraform</a:t>
             </a:r>
             <a:endParaRPr lang="en-US" sz="900" dirty="0"/>
           </a:p>
@@ -2291,14 +2271,14 @@
       </p:sp>
       <p:sp>
         <p:nvSpPr>
-          <p:cNvPr id="45" name="Shape 43"/>
-          <p:cNvSpPr/>
-          <p:nvPr/>
-        </p:nvSpPr>
-        <p:spPr>
-          <a:xfrm>
-            <a:off x="7315200" y="4645152"/>
-            <a:ext cx="1645920" cy="237744"/>
+          <p:cNvPr id="42" name="Shape 40"/>
+          <p:cNvSpPr/>
+          <p:nvPr/>
+        </p:nvSpPr>
+        <p:spPr>
+          <a:xfrm>
+            <a:off x="7232904" y="4663440"/>
+            <a:ext cx="1645920" cy="228600"/>
           </a:xfrm>
           <a:prstGeom prst="rect">
             <a:avLst/>
@@ -2306,24 +2286,31 @@
           <a:solidFill>
             <a:srgbClr val="0D1B2A"/>
           </a:solidFill>
-          <a:ln w="7620">
+          <a:ln w="8890">
             <a:solidFill>
               <a:srgbClr val="F4C0D1"/>
             </a:solidFill>
             <a:prstDash val="solid"/>
           </a:ln>
         </p:spPr>
-      </p:sp>
-      <p:sp>
-        <p:nvSpPr>
-          <p:cNvPr id="46" name="Text 44"/>
-          <p:cNvSpPr/>
-          <p:nvPr/>
-        </p:nvSpPr>
-        <p:spPr>
-          <a:xfrm>
-            <a:off x="7333488" y="4663440"/>
-            <a:ext cx="1609344" cy="201168"/>
+        <p:txBody>
+          <a:bodyPr/>
+          <a:lstStyle/>
+          <a:p>
+            <a:endParaRPr lang="en-US"/>
+          </a:p>
+        </p:txBody>
+      </p:sp>
+      <p:sp>
+        <p:nvSpPr>
+          <p:cNvPr id="43" name="Text 41"/>
+          <p:cNvSpPr/>
+          <p:nvPr/>
+        </p:nvSpPr>
+        <p:spPr>
+          <a:xfrm>
+            <a:off x="7251192" y="4681728"/>
+            <a:ext cx="1609344" cy="192024"/>
           </a:xfrm>
           <a:prstGeom prst="rect">
             <a:avLst/>
@@ -2335,7 +2322,7 @@
           <a:bodyPr wrap="square" lIns="0" tIns="0" rIns="0" bIns="0" rtlCol="0" anchor="ctr"/>
           <a:lstStyle/>
           <a:p>
-            <a:pPr algn="ctr" indent="0" marL="0">
+            <a:pPr marL="0" indent="0" algn="ctr">
               <a:buNone/>
             </a:pPr>
             <a:r>
@@ -2347,7 +2334,7 @@
                 <a:ea typeface="Calibri" pitchFamily="34" charset="-122"/>
                 <a:cs typeface="Calibri" pitchFamily="34" charset="-120"/>
               </a:rPr>
-              <a:t>Wk 7: S3 + IAM</a:t>
+              <a:t>S3 + IAM</a:t>
             </a:r>
             <a:endParaRPr lang="en-US" sz="900" dirty="0"/>
           </a:p>
@@ -2654,4 +2641,319 @@
     </a:ext>
   </a:extLst>
 </a:theme>
+</file>
+
+<file path=ppt/theme/theme2.xml><?xml version="1.0" encoding="utf-8"?>
+<a:theme xmlns:a="http://schemas.openxmlformats.org/drawingml/2006/main" name="Office Theme">
+  <a:themeElements>
+    <a:clrScheme name="Office">
+      <a:dk1>
+        <a:sysClr val="windowText" lastClr="000000"/>
+      </a:dk1>
+      <a:lt1>
+        <a:sysClr val="window" lastClr="FFFFFF"/>
+      </a:lt1>
+      <a:dk2>
+        <a:srgbClr val="0E2841"/>
+      </a:dk2>
+      <a:lt2>
+        <a:srgbClr val="E8E8E8"/>
+      </a:lt2>
+      <a:accent1>
+        <a:srgbClr val="156082"/>
+      </a:accent1>
+      <a:accent2>
+        <a:srgbClr val="E97132"/>
+      </a:accent2>
+      <a:accent3>
+        <a:srgbClr val="196B24"/>
+      </a:accent3>
+      <a:accent4>
+        <a:srgbClr val="0F9ED5"/>
+      </a:accent4>
+      <a:accent5>
+        <a:srgbClr val="A02B93"/>
+      </a:accent5>
+      <a:accent6>
+        <a:srgbClr val="4EA72E"/>
+      </a:accent6>
+      <a:hlink>
+        <a:srgbClr val="467886"/>
+      </a:hlink>
+      <a:folHlink>
+        <a:srgbClr val="96607D"/>
+      </a:folHlink>
+    </a:clrScheme>
+    <a:fontScheme name="Office">
+      <a:majorFont>
+        <a:latin typeface="Aptos Display" panose="02110004020202020204"/>
+        <a:ea typeface=""/>
+        <a:cs typeface=""/>
+        <a:font script="Jpan" typeface="游ゴシック Light"/>
+        <a:font script="Hang" typeface="맑은 고딕"/>
+        <a:font script="Hans" typeface="等线 Light"/>
+        <a:font script="Hant" typeface="新細明體"/>
+        <a:font script="Arab" typeface="Times New Roman"/>
+        <a:font script="Hebr" typeface="Times New Roman"/>
+        <a:font script="Thai" typeface="Angsana New"/>
+        <a:font script="Ethi" typeface="Nyala"/>
+        <a:font script="Beng" typeface="Vrinda"/>
+        <a:font script="Gujr" typeface="Shruti"/>
+        <a:font script="Khmr" typeface="MoolBoran"/>
+        <a:font script="Knda" typeface="Tunga"/>
+        <a:font script="Guru" typeface="Raavi"/>
+        <a:font script="Cans" typeface="Euphemia"/>
+        <a:font script="Cher" typeface="Plantagenet Cherokee"/>
+        <a:font script="Yiii" typeface="Microsoft Yi Baiti"/>
+        <a:font script="Tibt" typeface="Microsoft Himalaya"/>
+        <a:font script="Thaa" typeface="MV Boli"/>
+        <a:font script="Deva" typeface="Mangal"/>
+        <a:font script="Telu" typeface="Gautami"/>
+        <a:font script="Taml" typeface="Latha"/>
+        <a:font script="Syrc" typeface="Estrangelo Edessa"/>
+        <a:font script="Orya" typeface="Kalinga"/>
+        <a:font script="Mlym" typeface="Kartika"/>
+        <a:font script="Laoo" typeface="DokChampa"/>
+        <a:font script="Sinh" typeface="Iskoola Pota"/>
+        <a:font script="Mong" typeface="Mongolian Baiti"/>
+        <a:font script="Viet" typeface="Times New Roman"/>
+        <a:font script="Uigh" typeface="Microsoft Uighur"/>
+        <a:font script="Geor" typeface="Sylfaen"/>
+        <a:font script="Armn" typeface="Arial"/>
+        <a:font script="Bugi" typeface="Leelawadee UI"/>
+        <a:font script="Bopo" typeface="Microsoft JhengHei"/>
+        <a:font script="Java" typeface="Javanese Text"/>
+        <a:font script="Lisu" typeface="Segoe UI"/>
+        <a:font script="Mymr" typeface="Myanmar Text"/>
+        <a:font script="Nkoo" typeface="Ebrima"/>
+        <a:font script="Olck" typeface="Nirmala UI"/>
+        <a:font script="Osma" typeface="Ebrima"/>
+        <a:font script="Phag" typeface="Phagspa"/>
+        <a:font script="Syrn" typeface="Estrangelo Edessa"/>
+        <a:font script="Syrj" typeface="Estrangelo Edessa"/>
+        <a:font script="Syre" typeface="Estrangelo Edessa"/>
+        <a:font script="Sora" typeface="Nirmala UI"/>
+        <a:font script="Tale" typeface="Microsoft Tai Le"/>
+        <a:font script="Talu" typeface="Microsoft New Tai Lue"/>
+        <a:font script="Tfng" typeface="Ebrima"/>
+      </a:majorFont>
+      <a:minorFont>
+        <a:latin typeface="Aptos" panose="02110004020202020204"/>
+        <a:ea typeface=""/>
+        <a:cs typeface=""/>
+        <a:font script="Jpan" typeface="游ゴシック"/>
+        <a:font script="Hang" typeface="맑은 고딕"/>
+        <a:font script="Hans" typeface="等线"/>
+        <a:font script="Hant" typeface="新細明體"/>
+        <a:font script="Arab" typeface="Arial"/>
+        <a:font script="Hebr" typeface="Arial"/>
+        <a:font script="Thai" typeface="Cordia New"/>
+        <a:font script="Ethi" typeface="Nyala"/>
+        <a:font script="Beng" typeface="Vrinda"/>
+        <a:font script="Gujr" typeface="Shruti"/>
+        <a:font script="Khmr" typeface="DaunPenh"/>
+        <a:font script="Knda" typeface="Tunga"/>
+        <a:font script="Guru" typeface="Raavi"/>
+        <a:font script="Cans" typeface="Euphemia"/>
+        <a:font script="Cher" typeface="Plantagenet Cherokee"/>
+        <a:font script="Yiii" typeface="Microsoft Yi Baiti"/>
+        <a:font script="Tibt" typeface="Microsoft Himalaya"/>
+        <a:font script="Thaa" typeface="MV Boli"/>
+        <a:font script="Deva" typeface="Mangal"/>
+        <a:font script="Telu" typeface="Gautami"/>
+        <a:font script="Taml" typeface="Latha"/>
+        <a:font script="Syrc" typeface="Estrangelo Edessa"/>
+        <a:font script="Orya" typeface="Kalinga"/>
+        <a:font script="Mlym" typeface="Kartika"/>
+        <a:font script="Laoo" typeface="DokChampa"/>
+        <a:font script="Sinh" typeface="Iskoola Pota"/>
+        <a:font script="Mong" typeface="Mongolian Baiti"/>
+        <a:font script="Viet" typeface="Arial"/>
+        <a:font script="Uigh" typeface="Microsoft Uighur"/>
+        <a:font script="Geor" typeface="Sylfaen"/>
+        <a:font script="Armn" typeface="Arial"/>
+        <a:font script="Bugi" typeface="Leelawadee UI"/>
+        <a:font script="Bopo" typeface="Microsoft JhengHei"/>
+        <a:font script="Java" typeface="Javanese Text"/>
+        <a:font script="Lisu" typeface="Segoe UI"/>
+        <a:font script="Mymr" typeface="Myanmar Text"/>
+        <a:font script="Nkoo" typeface="Ebrima"/>
+        <a:font script="Olck" typeface="Nirmala UI"/>
+        <a:font script="Osma" typeface="Ebrima"/>
+        <a:font script="Phag" typeface="Phagspa"/>
+        <a:font script="Syrn" typeface="Estrangelo Edessa"/>
+        <a:font script="Syrj" typeface="Estrangelo Edessa"/>
+        <a:font script="Syre" typeface="Estrangelo Edessa"/>
+        <a:font script="Sora" typeface="Nirmala UI"/>
+        <a:font script="Tale" typeface="Microsoft Tai Le"/>
+        <a:font script="Talu" typeface="Microsoft New Tai Lue"/>
+        <a:font script="Tfng" typeface="Ebrima"/>
+      </a:minorFont>
+    </a:fontScheme>
+    <a:fmtScheme name="Office">
+      <a:fillStyleLst>
+        <a:solidFill>
+          <a:schemeClr val="phClr"/>
+        </a:solidFill>
+        <a:gradFill rotWithShape="1">
+          <a:gsLst>
+            <a:gs pos="0">
+              <a:schemeClr val="phClr">
+                <a:lumMod val="110000"/>
+                <a:satMod val="105000"/>
+                <a:tint val="67000"/>
+              </a:schemeClr>
+            </a:gs>
+            <a:gs pos="50000">
+              <a:schemeClr val="phClr">
+                <a:lumMod val="105000"/>
+                <a:satMod val="103000"/>
+                <a:tint val="73000"/>
+              </a:schemeClr>
+            </a:gs>
+            <a:gs pos="100000">
+              <a:schemeClr val="phClr">
+                <a:lumMod val="105000"/>
+                <a:satMod val="109000"/>
+                <a:tint val="81000"/>
+              </a:schemeClr>
+            </a:gs>
+          </a:gsLst>
+          <a:lin ang="5400000" scaled="0"/>
+        </a:gradFill>
+        <a:gradFill rotWithShape="1">
+          <a:gsLst>
+            <a:gs pos="0">
+              <a:schemeClr val="phClr">
+                <a:satMod val="103000"/>
+                <a:lumMod val="102000"/>
+                <a:tint val="94000"/>
+              </a:schemeClr>
+            </a:gs>
+            <a:gs pos="50000">
+              <a:schemeClr val="phClr">
+                <a:satMod val="110000"/>
+                <a:lumMod val="100000"/>
+                <a:shade val="100000"/>
+              </a:schemeClr>
+            </a:gs>
+            <a:gs pos="100000">
+              <a:schemeClr val="phClr">
+                <a:lumMod val="99000"/>
+                <a:satMod val="120000"/>
+                <a:shade val="78000"/>
+              </a:schemeClr>
+            </a:gs>
+          </a:gsLst>
+          <a:lin ang="5400000" scaled="0"/>
+        </a:gradFill>
+      </a:fillStyleLst>
+      <a:lnStyleLst>
+        <a:ln w="12700" cap="flat" cmpd="sng" algn="ctr">
+          <a:solidFill>
+            <a:schemeClr val="phClr"/>
+          </a:solidFill>
+          <a:prstDash val="solid"/>
+          <a:miter lim="800000"/>
+        </a:ln>
+        <a:ln w="19050" cap="flat" cmpd="sng" algn="ctr">
+          <a:solidFill>
+            <a:schemeClr val="phClr"/>
+          </a:solidFill>
+          <a:prstDash val="solid"/>
+          <a:miter lim="800000"/>
+        </a:ln>
+        <a:ln w="25400" cap="flat" cmpd="sng" algn="ctr">
+          <a:solidFill>
+            <a:schemeClr val="phClr"/>
+          </a:solidFill>
+          <a:prstDash val="solid"/>
+          <a:miter lim="800000"/>
+        </a:ln>
+      </a:lnStyleLst>
+      <a:effectStyleLst>
+        <a:effectStyle>
+          <a:effectLst/>
+        </a:effectStyle>
+        <a:effectStyle>
+          <a:effectLst/>
+        </a:effectStyle>
+        <a:effectStyle>
+          <a:effectLst>
+            <a:outerShdw blurRad="57150" dist="19050" dir="5400000" algn="ctr" rotWithShape="0">
+              <a:srgbClr val="000000">
+                <a:alpha val="63000"/>
+              </a:srgbClr>
+            </a:outerShdw>
+          </a:effectLst>
+        </a:effectStyle>
+      </a:effectStyleLst>
+      <a:bgFillStyleLst>
+        <a:solidFill>
+          <a:schemeClr val="phClr"/>
+        </a:solidFill>
+        <a:solidFill>
+          <a:schemeClr val="phClr">
+            <a:tint val="95000"/>
+            <a:satMod val="170000"/>
+          </a:schemeClr>
+        </a:solidFill>
+        <a:gradFill rotWithShape="1">
+          <a:gsLst>
+            <a:gs pos="0">
+              <a:schemeClr val="phClr">
+                <a:tint val="93000"/>
+                <a:satMod val="150000"/>
+                <a:shade val="98000"/>
+                <a:lumMod val="102000"/>
+              </a:schemeClr>
+            </a:gs>
+            <a:gs pos="50000">
+              <a:schemeClr val="phClr">
+                <a:tint val="98000"/>
+                <a:satMod val="130000"/>
+                <a:shade val="90000"/>
+                <a:lumMod val="103000"/>
+              </a:schemeClr>
+            </a:gs>
+            <a:gs pos="100000">
+              <a:schemeClr val="phClr">
+                <a:shade val="63000"/>
+                <a:satMod val="120000"/>
+              </a:schemeClr>
+            </a:gs>
+          </a:gsLst>
+          <a:lin ang="5400000" scaled="0"/>
+        </a:gradFill>
+      </a:bgFillStyleLst>
+    </a:fmtScheme>
+  </a:themeElements>
+  <a:objectDefaults>
+    <a:lnDef>
+      <a:spPr/>
+      <a:bodyPr/>
+      <a:lstStyle/>
+      <a:style>
+        <a:lnRef idx="2">
+          <a:schemeClr val="accent1"/>
+        </a:lnRef>
+        <a:fillRef idx="0">
+          <a:schemeClr val="accent1"/>
+        </a:fillRef>
+        <a:effectRef idx="1">
+          <a:schemeClr val="accent1"/>
+        </a:effectRef>
+        <a:fontRef idx="minor">
+          <a:schemeClr val="tx1"/>
+        </a:fontRef>
+      </a:style>
+    </a:lnDef>
+  </a:objectDefaults>
+  <a:extraClrSchemeLst/>
+  <a:extLst>
+    <a:ext uri="{05A4C25C-085E-4340-85A3-A5531E510DB2}">
+      <thm15:themeFamily xmlns:thm15="http://schemas.microsoft.com/office/thememl/2012/main" name="Office Theme" id="{2E142A2C-CD16-42D6-873A-C26D2A0506FA}" vid="{1BDDFF52-6CD6-40A5-AB3C-68EB2F1E4D0A}"/>
+    </a:ext>
+  </a:extLst>
+</a:theme>
 </file>
</xml_diff>